<commit_message>
Match deck to new Aéza design language; sharpen screenshots
Фронтенд получил новый дизайн (c30f88b: токен --brand-500 #ff6b00, акцент
aeza.ru, Manrope). Пересобрал снимки интерфейса с работающего стенда, чтобы
колода не показывала прежний вид, и подтянул акцент слайдов к токену продукта:
коралловый #F97415 → #FF6B00, тёмный вариант для светлого фона #B84A00
(контраст 4,75:1 — выше порога 4,5).

Слайд 3 — сетка метрик во всю правую колонку (было мелкое изображение);
слайд 7 — карточки «до/после» пересняты в 3x DPR, читаемость 189 px/дюйм.

qa_visual.py теперь берёт палитру из deckkit, а не из своей копии: раньше
проверка контраста считала старые цвета и не заметила бы регресс.

Проверено: validate.py — 0 замечаний (оба файла); qa_visual.py — читаемость
189–2371 px/дюйм, контраст 4,75:1 и выше; пересборка из docs/deck проходит.
</commit_message>
<xml_diff>
--- a/aeza_hackathon_osen_2026.pptx
+++ b/aeza_hackathon_osen_2026.pptx
@@ -142,7 +142,7 @@
           </c:tx>
           <c:spPr>
             <a:solidFill>
-              <a:srgbClr val="F97415"/>
+              <a:srgbClr val="FF6B00"/>
             </a:solidFill>
           </c:spPr>
           <c:cat>
@@ -5004,7 +5004,7 @@
             <a:avLst/>
           </a:prstGeom>
           <a:solidFill>
-            <a:srgbClr val="F97415"/>
+            <a:srgbClr val="FF6B00"/>
           </a:solidFill>
           <a:ln>
             <a:noFill/>
@@ -5187,7 +5187,7 @@
             <a:r>
               <a:rPr sz="4400" b="1" i="0">
                 <a:solidFill>
-                  <a:srgbClr val="F97415"/>
+                  <a:srgbClr val="FF6B00"/>
                 </a:solidFill>
                 <a:latin typeface="Manrope"/>
                 <a:cs typeface="Manrope"/>
@@ -5831,7 +5831,7 @@
             <a:avLst/>
           </a:prstGeom>
           <a:solidFill>
-            <a:srgbClr val="F97415"/>
+            <a:srgbClr val="FF6B00"/>
           </a:solidFill>
           <a:ln>
             <a:noFill/>
@@ -6014,7 +6014,7 @@
             <a:r>
               <a:rPr sz="2500" b="1" i="0">
                 <a:solidFill>
-                  <a:srgbClr val="F97415"/>
+                  <a:srgbClr val="FF6B00"/>
                 </a:solidFill>
                 <a:latin typeface="Manrope SemiBold"/>
                 <a:cs typeface="Manrope SemiBold"/>
@@ -6038,7 +6038,7 @@
             <a:r>
               <a:rPr sz="2500" b="1" i="0">
                 <a:solidFill>
-                  <a:srgbClr val="F97415"/>
+                  <a:srgbClr val="FF6B00"/>
                 </a:solidFill>
                 <a:latin typeface="Manrope SemiBold"/>
                 <a:cs typeface="Manrope SemiBold"/>
@@ -7054,7 +7054,7 @@
             <a:r>
               <a:rPr sz="1050" b="1" i="0" spc="140">
                 <a:solidFill>
-                  <a:srgbClr val="B34A0A"/>
+                  <a:srgbClr val="B84A00"/>
                 </a:solidFill>
                 <a:latin typeface="Manrope"/>
                 <a:cs typeface="Manrope"/>
@@ -7926,7 +7926,7 @@
             <a:avLst/>
           </a:prstGeom>
           <a:solidFill>
-            <a:srgbClr val="B34A0A"/>
+            <a:srgbClr val="B84A00"/>
           </a:solidFill>
           <a:ln>
             <a:noFill/>
@@ -7970,7 +7970,7 @@
             <a:avLst/>
           </a:prstGeom>
           <a:solidFill>
-            <a:srgbClr val="B34A0A"/>
+            <a:srgbClr val="B84A00"/>
           </a:solidFill>
           <a:ln>
             <a:noFill/>
@@ -8386,7 +8386,7 @@
             <a:r>
               <a:rPr sz="2500" b="1" i="0">
                 <a:solidFill>
-                  <a:srgbClr val="B34A0A"/>
+                  <a:srgbClr val="B84A00"/>
                 </a:solidFill>
                 <a:latin typeface="Manrope"/>
                 <a:cs typeface="Manrope"/>
@@ -8524,7 +8524,7 @@
             <a:r>
               <a:rPr sz="2500" b="1" i="0">
                 <a:solidFill>
-                  <a:srgbClr val="B34A0A"/>
+                  <a:srgbClr val="B84A00"/>
                 </a:solidFill>
                 <a:latin typeface="Manrope"/>
                 <a:cs typeface="Manrope"/>
@@ -8662,7 +8662,7 @@
             <a:r>
               <a:rPr sz="2500" b="1" i="0">
                 <a:solidFill>
-                  <a:srgbClr val="B34A0A"/>
+                  <a:srgbClr val="B84A00"/>
                 </a:solidFill>
                 <a:latin typeface="Manrope"/>
                 <a:cs typeface="Manrope"/>
@@ -8800,7 +8800,7 @@
             <a:r>
               <a:rPr sz="2500" b="1" i="0">
                 <a:solidFill>
-                  <a:srgbClr val="B34A0A"/>
+                  <a:srgbClr val="B84A00"/>
                 </a:solidFill>
                 <a:latin typeface="Manrope"/>
                 <a:cs typeface="Manrope"/>
@@ -9047,7 +9047,7 @@
             <a:r>
               <a:rPr sz="1050" b="1" i="0" spc="140">
                 <a:solidFill>
-                  <a:srgbClr val="B34A0A"/>
+                  <a:srgbClr val="B84A00"/>
                 </a:solidFill>
                 <a:latin typeface="Manrope"/>
                 <a:cs typeface="Manrope"/>
@@ -9191,7 +9191,7 @@
             <a:avLst/>
           </a:prstGeom>
           <a:solidFill>
-            <a:srgbClr val="F97415"/>
+            <a:srgbClr val="FF6B00"/>
           </a:solidFill>
           <a:ln>
             <a:noFill/>
@@ -9374,7 +9374,7 @@
             <a:avLst/>
           </a:prstGeom>
           <a:solidFill>
-            <a:srgbClr val="F97415"/>
+            <a:srgbClr val="FF6B00"/>
           </a:solidFill>
           <a:ln>
             <a:noFill/>
@@ -9533,7 +9533,7 @@
             <a:avLst/>
           </a:prstGeom>
           <a:solidFill>
-            <a:srgbClr val="F97415"/>
+            <a:srgbClr val="FF6B00"/>
           </a:solidFill>
           <a:ln>
             <a:noFill/>
@@ -9692,7 +9692,7 @@
             <a:avLst/>
           </a:prstGeom>
           <a:solidFill>
-            <a:srgbClr val="F97415"/>
+            <a:srgbClr val="FF6B00"/>
           </a:solidFill>
           <a:ln>
             <a:noFill/>
@@ -9892,7 +9892,7 @@
         <p:spPr>
           <a:xfrm>
             <a:off x="626364" y="3012948"/>
-            <a:ext cx="6556248" cy="2029745"/>
+            <a:ext cx="6556248" cy="2418059"/>
           </a:xfrm>
           <a:prstGeom prst="rect">
             <a:avLst/>
@@ -9946,7 +9946,7 @@
         <p:spPr>
           <a:xfrm>
             <a:off x="658368" y="3044952"/>
-            <a:ext cx="6486932" cy="1965737"/>
+            <a:ext cx="6487678" cy="2354051"/>
           </a:xfrm>
           <a:prstGeom prst="rect">
             <a:avLst/>
@@ -9961,7 +9961,7 @@
         </p:nvSpPr>
         <p:spPr>
           <a:xfrm>
-            <a:off x="658368" y="5120417"/>
+            <a:off x="658368" y="5508731"/>
             <a:ext cx="6492240" cy="180848"/>
           </a:xfrm>
           <a:prstGeom prst="rect">
@@ -10056,7 +10056,7 @@
         <p:spPr>
           <a:xfrm>
             <a:off x="7392924" y="3012948"/>
-            <a:ext cx="4172407" cy="1137622"/>
+            <a:ext cx="4172407" cy="1346239"/>
           </a:xfrm>
           <a:prstGeom prst="rect">
             <a:avLst/>
@@ -10095,7 +10095,7 @@
       </p:sp>
       <p:pic>
         <p:nvPicPr>
-          <p:cNvPr id="24" name="Picture 23" descr="w_dash_metrics.png"/>
+          <p:cNvPr id="24" name="Picture 23" descr="w_dash_metrics6.png"/>
           <p:cNvPicPr>
             <a:picLocks noChangeAspect="1"/>
           </p:cNvPicPr>
@@ -10110,7 +10110,7 @@
         <p:spPr>
           <a:xfrm>
             <a:off x="7424928" y="3044952"/>
-            <a:ext cx="4108399" cy="1073609"/>
+            <a:ext cx="4093728" cy="1282231"/>
           </a:xfrm>
           <a:prstGeom prst="rect">
             <a:avLst/>
@@ -10125,8 +10125,8 @@
         </p:nvSpPr>
         <p:spPr>
           <a:xfrm>
-            <a:off x="7392924" y="4287730"/>
-            <a:ext cx="4172407" cy="1125993"/>
+            <a:off x="7392924" y="4496347"/>
+            <a:ext cx="4172407" cy="1297724"/>
           </a:xfrm>
           <a:prstGeom prst="rect">
             <a:avLst/>
@@ -10179,8 +10179,8 @@
         </p:blipFill>
         <p:spPr>
           <a:xfrm>
-            <a:off x="7424928" y="4319734"/>
-            <a:ext cx="4108399" cy="1061982"/>
+            <a:off x="7424928" y="4528351"/>
+            <a:ext cx="4101909" cy="1233716"/>
           </a:xfrm>
           <a:prstGeom prst="rect">
             <a:avLst/>
@@ -10195,7 +10195,7 @@
         </p:nvSpPr>
         <p:spPr>
           <a:xfrm>
-            <a:off x="7424928" y="5491447"/>
+            <a:off x="7424928" y="5871795"/>
             <a:ext cx="4108399" cy="343408"/>
           </a:xfrm>
           <a:prstGeom prst="rect">
@@ -10356,7 +10356,7 @@
             <a:r>
               <a:rPr sz="1050" b="1" i="0" spc="140">
                 <a:solidFill>
-                  <a:srgbClr val="B34A0A"/>
+                  <a:srgbClr val="B84A00"/>
                 </a:solidFill>
                 <a:latin typeface="Manrope"/>
                 <a:cs typeface="Manrope"/>
@@ -10642,7 +10642,7 @@
             </a:avLst>
           </a:prstGeom>
           <a:solidFill>
-            <a:srgbClr val="B34A0A"/>
+            <a:srgbClr val="B84A00"/>
           </a:solidFill>
           <a:ln>
             <a:noFill/>
@@ -10775,7 +10775,7 @@
             <a:r>
               <a:rPr sz="1400" b="1" i="0">
                 <a:solidFill>
-                  <a:srgbClr val="B34A0A"/>
+                  <a:srgbClr val="B84A00"/>
                 </a:solidFill>
                 <a:latin typeface="Manrope SemiBold"/>
                 <a:cs typeface="Manrope SemiBold"/>
@@ -11218,7 +11218,7 @@
         <p:spPr>
           <a:xfrm>
             <a:off x="4759452" y="2263140"/>
-            <a:ext cx="6805879" cy="303522"/>
+            <a:ext cx="6805879" cy="410011"/>
           </a:xfrm>
           <a:prstGeom prst="rect">
             <a:avLst/>
@@ -11272,7 +11272,7 @@
         <p:spPr>
           <a:xfrm>
             <a:off x="4791456" y="2295144"/>
-            <a:ext cx="6741871" cy="239513"/>
+            <a:ext cx="6671647" cy="346003"/>
           </a:xfrm>
           <a:prstGeom prst="rect">
             <a:avLst/>
@@ -11287,8 +11287,8 @@
         </p:nvSpPr>
         <p:spPr>
           <a:xfrm>
-            <a:off x="4759452" y="2612382"/>
-            <a:ext cx="3361791" cy="1024005"/>
+            <a:off x="4759452" y="2718871"/>
+            <a:ext cx="3361791" cy="1250858"/>
           </a:xfrm>
           <a:prstGeom prst="rect">
             <a:avLst/>
@@ -11341,8 +11341,8 @@
         </p:blipFill>
         <p:spPr>
           <a:xfrm>
-            <a:off x="4791456" y="2644386"/>
-            <a:ext cx="3297767" cy="959997"/>
+            <a:off x="4791456" y="2750875"/>
+            <a:ext cx="3297783" cy="1186839"/>
           </a:xfrm>
           <a:prstGeom prst="rect">
             <a:avLst/>
@@ -11357,8 +11357,8 @@
         </p:nvSpPr>
         <p:spPr>
           <a:xfrm>
-            <a:off x="8203539" y="2612382"/>
-            <a:ext cx="3361791" cy="1024005"/>
+            <a:off x="8203539" y="2718871"/>
+            <a:ext cx="3361791" cy="1250858"/>
           </a:xfrm>
           <a:prstGeom prst="rect">
             <a:avLst/>
@@ -11411,8 +11411,8 @@
         </p:blipFill>
         <p:spPr>
           <a:xfrm>
-            <a:off x="8235543" y="2644386"/>
-            <a:ext cx="3297767" cy="959997"/>
+            <a:off x="8235543" y="2750875"/>
+            <a:ext cx="3297783" cy="1186839"/>
           </a:xfrm>
           <a:prstGeom prst="rect">
             <a:avLst/>
@@ -11427,7 +11427,7 @@
         </p:nvSpPr>
         <p:spPr>
           <a:xfrm>
-            <a:off x="4791456" y="3842127"/>
+            <a:off x="4791456" y="4175469"/>
             <a:ext cx="6741871" cy="151003"/>
           </a:xfrm>
           <a:prstGeom prst="rect">
@@ -11474,8 +11474,8 @@
         </p:nvSpPr>
         <p:spPr>
           <a:xfrm>
-            <a:off x="4759452" y="4057011"/>
-            <a:ext cx="6805879" cy="1336059"/>
+            <a:off x="4759452" y="4390353"/>
+            <a:ext cx="6805879" cy="1513779"/>
           </a:xfrm>
           <a:prstGeom prst="rect">
             <a:avLst/>
@@ -11528,8 +11528,8 @@
         </p:blipFill>
         <p:spPr>
           <a:xfrm>
-            <a:off x="4791456" y="4089015"/>
-            <a:ext cx="6741871" cy="1272051"/>
+            <a:off x="4791456" y="4422357"/>
+            <a:ext cx="6697172" cy="1449771"/>
           </a:xfrm>
           <a:prstGeom prst="rect">
             <a:avLst/>
@@ -11544,7 +11544,7 @@
         </p:nvSpPr>
         <p:spPr>
           <a:xfrm>
-            <a:off x="4791456" y="5470794"/>
+            <a:off x="4791456" y="5981856"/>
             <a:ext cx="6741871" cy="364998"/>
           </a:xfrm>
           <a:prstGeom prst="rect">
@@ -11796,7 +11796,7 @@
             <a:r>
               <a:rPr sz="1050" b="1" i="0" spc="140">
                 <a:solidFill>
-                  <a:srgbClr val="B34A0A"/>
+                  <a:srgbClr val="B84A00"/>
                 </a:solidFill>
                 <a:latin typeface="Manrope"/>
                 <a:cs typeface="Manrope"/>
@@ -12513,7 +12513,7 @@
             <a:avLst/>
           </a:prstGeom>
           <a:solidFill>
-            <a:srgbClr val="B34A0A"/>
+            <a:srgbClr val="B84A00"/>
           </a:solidFill>
           <a:ln>
             <a:noFill/>
@@ -12897,7 +12897,7 @@
             <a:r>
               <a:rPr sz="1050" b="1" i="0" spc="140">
                 <a:solidFill>
-                  <a:srgbClr val="B34A0A"/>
+                  <a:srgbClr val="B84A00"/>
                 </a:solidFill>
                 <a:latin typeface="Manrope"/>
                 <a:cs typeface="Manrope"/>
@@ -13375,7 +13375,7 @@
             <a:r>
               <a:rPr sz="1350" b="1" i="0">
                 <a:solidFill>
-                  <a:srgbClr val="B34A0A"/>
+                  <a:srgbClr val="B84A00"/>
                 </a:solidFill>
                 <a:latin typeface="Manrope SemiBold"/>
                 <a:cs typeface="Manrope SemiBold"/>
@@ -13818,7 +13818,7 @@
         <p:spPr>
           <a:xfrm>
             <a:off x="4878323" y="3323844"/>
-            <a:ext cx="6687008" cy="1307592"/>
+            <a:ext cx="6687008" cy="1462829"/>
           </a:xfrm>
           <a:prstGeom prst="rect">
             <a:avLst/>
@@ -13872,7 +13872,7 @@
         <p:spPr>
           <a:xfrm>
             <a:off x="4910327" y="3355848"/>
-            <a:ext cx="6623000" cy="1210084"/>
+            <a:ext cx="6615883" cy="1398821"/>
           </a:xfrm>
           <a:prstGeom prst="rect">
             <a:avLst/>
@@ -14008,7 +14008,7 @@
             <a:r>
               <a:rPr sz="1600" b="1" i="0">
                 <a:solidFill>
-                  <a:srgbClr val="B34A0A"/>
+                  <a:srgbClr val="B84A00"/>
                 </a:solidFill>
                 <a:latin typeface="Manrope"/>
                 <a:cs typeface="Manrope"/>
@@ -14629,7 +14629,7 @@
             <a:r>
               <a:rPr sz="1050" b="1" i="0" spc="140">
                 <a:solidFill>
-                  <a:srgbClr val="B34A0A"/>
+                  <a:srgbClr val="B84A00"/>
                 </a:solidFill>
                 <a:latin typeface="Manrope"/>
                 <a:cs typeface="Manrope"/>
@@ -14819,7 +14819,7 @@
             <a:avLst/>
           </a:prstGeom>
           <a:solidFill>
-            <a:srgbClr val="B34A0A"/>
+            <a:srgbClr val="B84A00"/>
           </a:solidFill>
           <a:ln>
             <a:noFill/>
@@ -14884,7 +14884,7 @@
             <a:r>
               <a:rPr sz="1100" b="1">
                 <a:solidFill>
-                  <a:srgbClr val="B34A0A"/>
+                  <a:srgbClr val="B84A00"/>
                 </a:solidFill>
                 <a:latin typeface="Manrope"/>
                 <a:cs typeface="Manrope"/>
@@ -14989,7 +14989,7 @@
             <a:r>
               <a:rPr sz="950" b="1" i="0">
                 <a:solidFill>
-                  <a:srgbClr val="B34A0A"/>
+                  <a:srgbClr val="B84A00"/>
                 </a:solidFill>
                 <a:latin typeface="Manrope"/>
                 <a:cs typeface="Manrope"/>
@@ -15009,7 +15009,7 @@
         <p:spPr>
           <a:xfrm>
             <a:off x="626364" y="2921508"/>
-            <a:ext cx="5346039" cy="827594"/>
+            <a:ext cx="5346039" cy="1978550"/>
           </a:xfrm>
           <a:prstGeom prst="rect">
             <a:avLst/>
@@ -15063,7 +15063,7 @@
         <p:spPr>
           <a:xfrm>
             <a:off x="658368" y="2953512"/>
-            <a:ext cx="5282031" cy="763582"/>
+            <a:ext cx="5282031" cy="1900950"/>
           </a:xfrm>
           <a:prstGeom prst="rect">
             <a:avLst/>
@@ -15079,7 +15079,7 @@
         <p:spPr>
           <a:xfrm>
             <a:off x="6219291" y="2921508"/>
-            <a:ext cx="5346039" cy="827594"/>
+            <a:ext cx="5346039" cy="1978550"/>
           </a:xfrm>
           <a:prstGeom prst="rect">
             <a:avLst/>
@@ -15133,7 +15133,7 @@
         <p:spPr>
           <a:xfrm>
             <a:off x="6251295" y="2953512"/>
-            <a:ext cx="5282031" cy="763582"/>
+            <a:ext cx="5282031" cy="1900950"/>
           </a:xfrm>
           <a:prstGeom prst="rect">
             <a:avLst/>
@@ -15291,7 +15291,7 @@
             <a:r>
               <a:rPr sz="1500" b="1">
                 <a:solidFill>
-                  <a:srgbClr val="B34A0A"/>
+                  <a:srgbClr val="B84A00"/>
                 </a:solidFill>
                 <a:latin typeface="Manrope"/>
                 <a:cs typeface="Manrope"/>
@@ -15453,7 +15453,7 @@
             <a:r>
               <a:rPr sz="1500" b="1">
                 <a:solidFill>
-                  <a:srgbClr val="B34A0A"/>
+                  <a:srgbClr val="B84A00"/>
                 </a:solidFill>
                 <a:latin typeface="Manrope"/>
                 <a:cs typeface="Manrope"/>
@@ -15615,7 +15615,7 @@
             <a:r>
               <a:rPr sz="1500" b="1">
                 <a:solidFill>
-                  <a:srgbClr val="B34A0A"/>
+                  <a:srgbClr val="B84A00"/>
                 </a:solidFill>
                 <a:latin typeface="Manrope"/>
                 <a:cs typeface="Manrope"/>
@@ -15777,7 +15777,7 @@
             <a:r>
               <a:rPr sz="1500" b="1">
                 <a:solidFill>
-                  <a:srgbClr val="B34A0A"/>
+                  <a:srgbClr val="B84A00"/>
                 </a:solidFill>
                 <a:latin typeface="Manrope"/>
                 <a:cs typeface="Manrope"/>
@@ -15939,7 +15939,7 @@
             <a:r>
               <a:rPr sz="1500" b="1">
                 <a:solidFill>
-                  <a:srgbClr val="B34A0A"/>
+                  <a:srgbClr val="B84A00"/>
                 </a:solidFill>
                 <a:latin typeface="Manrope"/>
                 <a:cs typeface="Manrope"/>
@@ -16101,7 +16101,7 @@
             <a:r>
               <a:rPr sz="1500" b="1">
                 <a:solidFill>
-                  <a:srgbClr val="B34A0A"/>
+                  <a:srgbClr val="B84A00"/>
                 </a:solidFill>
                 <a:latin typeface="Manrope"/>
                 <a:cs typeface="Manrope"/>
@@ -16281,7 +16281,7 @@
             <a:r>
               <a:rPr sz="1050" b="1" i="0" spc="140">
                 <a:solidFill>
-                  <a:srgbClr val="B34A0A"/>
+                  <a:srgbClr val="B84A00"/>
                 </a:solidFill>
                 <a:latin typeface="Manrope"/>
                 <a:cs typeface="Manrope"/>
@@ -17279,7 +17279,7 @@
             <a:avLst/>
           </a:prstGeom>
           <a:solidFill>
-            <a:srgbClr val="B34A0A"/>
+            <a:srgbClr val="B84A00"/>
           </a:solidFill>
           <a:ln>
             <a:noFill/>
@@ -17615,7 +17615,7 @@
             <a:r>
               <a:rPr sz="1050" b="1" i="0" spc="140">
                 <a:solidFill>
-                  <a:srgbClr val="B34A0A"/>
+                  <a:srgbClr val="B84A00"/>
                 </a:solidFill>
                 <a:latin typeface="Manrope"/>
                 <a:cs typeface="Manrope"/>
@@ -18537,7 +18537,7 @@
             <a:avLst/>
           </a:prstGeom>
           <a:solidFill>
-            <a:srgbClr val="B34A0A"/>
+            <a:srgbClr val="B84A00"/>
           </a:solidFill>
           <a:ln>
             <a:noFill/>

</xml_diff>

<commit_message>
Rebuild the defence deck so it matches the current product
The deck recomputes every figure by importing backend/app/domain and running
it over dataset/data.json, so the approved methodology change silently made
the committed artefacts stale. The old PDF still showed the pre-change
numbers (5,74 EUR, customer 10 at 73.3) while the product now reports
5,80 EUR and 71.4 - exactly the divergence between slides and product the
task warns about.

Regenerated both:
- build_deck.py rerun for the PPTX (5,80 EUR / 17,03 EUR / 71.4);
- LibreOffice Impress for the PDF, which the Python script does not produce.

Verified by extracting the PDF text: it now contains 5,80 and 71.4 and no
longer contains 5,74 or 73.3. No slide content was hand-edited and no
placeholder was replaced with an invented number.

Note for rebuilding locally: the deck needs python-pptx, and the PDF needs a
working LibreOffice (soffice --headless --convert-to pdf).
</commit_message>
<xml_diff>
--- a/aeza_hackathon_osen_2026.pptx
+++ b/aeza_hackathon_osen_2026.pptx
@@ -7159,7 +7159,7 @@
                 <a:ea typeface="Inter"/>
                 <a:cs typeface="Inter"/>
               </a:rPr>
-              <a:t>73.3</a:t>
+              <a:t>71.4</a:t>
             </a:r>
           </a:p>
         </p:txBody>
@@ -7391,7 +7391,7 @@
                 <a:ea typeface="Inter"/>
                 <a:cs typeface="Inter"/>
               </a:rPr>
-              <a:t>1 услуга</a:t>
+              <a:t>2 услуги</a:t>
             </a:r>
             <a:r>
               <a:rPr sz="1250" b="0">
@@ -7542,7 +7542,7 @@
                 <a:ea typeface="Inter"/>
                 <a:cs typeface="Inter"/>
               </a:rPr>
-              <a:t>Идентификатор клиента взят из датасета; адрес не показываем. Критичная услуга — service-0030: 73.3 балла, стоимость продления 7,02 €.</a:t>
+              <a:t>Идентификатор клиента взят из датасета; адрес не показываем. Критичная услуга — service-0030: 71.4 балла, стоимость продления 7,02 €.</a:t>
             </a:r>
           </a:p>
         </p:txBody>
@@ -8611,7 +8611,7 @@
                 <a:ea typeface="Inter"/>
                 <a:cs typeface="Inter"/>
               </a:rPr>
-              <a:t>вес 2</a:t>
+              <a:t>вес 0</a:t>
             </a:r>
           </a:p>
         </p:txBody>
@@ -8660,14 +8660,488 @@
       </p:sp>
       <p:sp>
         <p:nvSpPr>
-          <p:cNvPr id="29" name="Rectangle 28"/>
+          <p:cNvPr id="29" name="TextBox 28"/>
+          <p:cNvSpPr txBox="1"/>
+          <p:nvPr/>
+        </p:nvSpPr>
+        <p:spPr>
+          <a:xfrm>
+            <a:off x="6675120" y="4453128"/>
+            <a:ext cx="868680" cy="310896"/>
+          </a:xfrm>
+          <a:prstGeom prst="rect">
+            <a:avLst/>
+          </a:prstGeom>
+          <a:noFill/>
+        </p:spPr>
+        <p:txBody>
+          <a:bodyPr wrap="square" anchor="t" lIns="0" rIns="0" tIns="0" bIns="0">
+            <a:spAutoFit/>
+          </a:bodyPr>
+          <a:lstStyle/>
+          <a:p>
+            <a:pPr algn="r"/>
+            <a:r>
+              <a:rPr sz="1250" b="1" i="0">
+                <a:solidFill>
+                  <a:srgbClr val="202B3A"/>
+                </a:solidFill>
+                <a:latin typeface="Inter"/>
+                <a:ea typeface="Inter"/>
+                <a:cs typeface="Inter"/>
+              </a:rPr>
+              <a:t>0.0</a:t>
+            </a:r>
+          </a:p>
+        </p:txBody>
+      </p:sp>
+      <p:sp>
+        <p:nvSpPr>
+          <p:cNvPr id="30" name="TextBox 29"/>
+          <p:cNvSpPr txBox="1"/>
+          <p:nvPr/>
+        </p:nvSpPr>
+        <p:spPr>
+          <a:xfrm>
+            <a:off x="777240" y="4873752"/>
+            <a:ext cx="3035808" cy="310896"/>
+          </a:xfrm>
+          <a:prstGeom prst="rect">
+            <a:avLst/>
+          </a:prstGeom>
+          <a:noFill/>
+        </p:spPr>
+        <p:txBody>
+          <a:bodyPr wrap="square" anchor="t" lIns="0" rIns="0" tIns="0" bIns="0">
+            <a:spAutoFit/>
+          </a:bodyPr>
+          <a:lstStyle/>
+          <a:p>
+            <a:pPr algn="l"/>
+            <a:r>
+              <a:rPr sz="1200" b="1" i="0">
+                <a:solidFill>
+                  <a:srgbClr val="202B3A"/>
+                </a:solidFill>
+                <a:latin typeface="Inter"/>
+                <a:ea typeface="Inter"/>
+                <a:cs typeface="Inter"/>
+              </a:rPr>
+              <a:t>Услуга приостановлена</a:t>
+            </a:r>
+          </a:p>
+        </p:txBody>
+      </p:sp>
+      <p:sp>
+        <p:nvSpPr>
+          <p:cNvPr id="31" name="TextBox 30"/>
+          <p:cNvSpPr txBox="1"/>
+          <p:nvPr/>
+        </p:nvSpPr>
+        <p:spPr>
+          <a:xfrm>
+            <a:off x="3849624" y="4873752"/>
+            <a:ext cx="1170432" cy="310896"/>
+          </a:xfrm>
+          <a:prstGeom prst="rect">
+            <a:avLst/>
+          </a:prstGeom>
+          <a:noFill/>
+        </p:spPr>
+        <p:txBody>
+          <a:bodyPr wrap="square" anchor="t" lIns="0" rIns="0" tIns="0" bIns="0">
+            <a:spAutoFit/>
+          </a:bodyPr>
+          <a:lstStyle/>
+          <a:p>
+            <a:pPr algn="r"/>
+            <a:r>
+              <a:rPr sz="1150" b="0" i="0">
+                <a:solidFill>
+                  <a:srgbClr val="6B7480"/>
+                </a:solidFill>
+                <a:latin typeface="Inter"/>
+                <a:ea typeface="Inter"/>
+                <a:cs typeface="Inter"/>
+              </a:rPr>
+              <a:t>вес 1</a:t>
+            </a:r>
+          </a:p>
+        </p:txBody>
+      </p:sp>
+      <p:sp>
+        <p:nvSpPr>
+          <p:cNvPr id="32" name="Rectangle 31"/>
           <p:cNvSpPr/>
           <p:nvPr/>
         </p:nvSpPr>
         <p:spPr>
           <a:xfrm>
-            <a:off x="5166360" y="4498848"/>
-            <a:ext cx="944880" cy="118872"/>
+            <a:off x="5166360" y="4919472"/>
+            <a:ext cx="1417320" cy="118872"/>
+          </a:xfrm>
+          <a:prstGeom prst="rect">
+            <a:avLst/>
+          </a:prstGeom>
+          <a:solidFill>
+            <a:srgbClr val="D9DEE2"/>
+          </a:solidFill>
+          <a:ln>
+            <a:noFill/>
+          </a:ln>
+          <a:effectLst/>
+        </p:spPr>
+        <p:style>
+          <a:lnRef idx="1">
+            <a:schemeClr val="accent1"/>
+          </a:lnRef>
+          <a:fillRef idx="3">
+            <a:schemeClr val="accent1"/>
+          </a:fillRef>
+          <a:effectRef idx="2">
+            <a:schemeClr val="accent1"/>
+          </a:effectRef>
+          <a:fontRef idx="minor">
+            <a:schemeClr val="lt1"/>
+          </a:fontRef>
+        </p:style>
+        <p:txBody>
+          <a:bodyPr rtlCol="0" anchor="ctr"/>
+          <a:lstStyle/>
+          <a:p/>
+        </p:txBody>
+      </p:sp>
+      <p:sp>
+        <p:nvSpPr>
+          <p:cNvPr id="33" name="TextBox 32"/>
+          <p:cNvSpPr txBox="1"/>
+          <p:nvPr/>
+        </p:nvSpPr>
+        <p:spPr>
+          <a:xfrm>
+            <a:off x="6675120" y="4873752"/>
+            <a:ext cx="868680" cy="310896"/>
+          </a:xfrm>
+          <a:prstGeom prst="rect">
+            <a:avLst/>
+          </a:prstGeom>
+          <a:noFill/>
+        </p:spPr>
+        <p:txBody>
+          <a:bodyPr wrap="square" anchor="t" lIns="0" rIns="0" tIns="0" bIns="0">
+            <a:spAutoFit/>
+          </a:bodyPr>
+          <a:lstStyle/>
+          <a:p>
+            <a:pPr algn="r"/>
+            <a:r>
+              <a:rPr sz="1250" b="1" i="0">
+                <a:solidFill>
+                  <a:srgbClr val="202B3A"/>
+                </a:solidFill>
+                <a:latin typeface="Inter"/>
+                <a:ea typeface="Inter"/>
+                <a:cs typeface="Inter"/>
+              </a:rPr>
+              <a:t>0.0</a:t>
+            </a:r>
+          </a:p>
+        </p:txBody>
+      </p:sp>
+      <p:sp>
+        <p:nvSpPr>
+          <p:cNvPr id="34" name="TextBox 33"/>
+          <p:cNvSpPr txBox="1"/>
+          <p:nvPr/>
+        </p:nvSpPr>
+        <p:spPr>
+          <a:xfrm>
+            <a:off x="777240" y="5294376"/>
+            <a:ext cx="3035808" cy="310896"/>
+          </a:xfrm>
+          <a:prstGeom prst="rect">
+            <a:avLst/>
+          </a:prstGeom>
+          <a:noFill/>
+        </p:spPr>
+        <p:txBody>
+          <a:bodyPr wrap="square" anchor="t" lIns="0" rIns="0" tIns="0" bIns="0">
+            <a:spAutoFit/>
+          </a:bodyPr>
+          <a:lstStyle/>
+          <a:p>
+            <a:pPr algn="l"/>
+            <a:r>
+              <a:rPr sz="1200" b="1" i="0">
+                <a:solidFill>
+                  <a:srgbClr val="202B3A"/>
+                </a:solidFill>
+                <a:latin typeface="Inter"/>
+                <a:ea typeface="Inter"/>
+                <a:cs typeface="Inter"/>
+              </a:rPr>
+              <a:t>Доля неуспешных продлений</a:t>
+            </a:r>
+          </a:p>
+        </p:txBody>
+      </p:sp>
+      <p:sp>
+        <p:nvSpPr>
+          <p:cNvPr id="35" name="TextBox 34"/>
+          <p:cNvSpPr txBox="1"/>
+          <p:nvPr/>
+        </p:nvSpPr>
+        <p:spPr>
+          <a:xfrm>
+            <a:off x="3849624" y="5294376"/>
+            <a:ext cx="1170432" cy="310896"/>
+          </a:xfrm>
+          <a:prstGeom prst="rect">
+            <a:avLst/>
+          </a:prstGeom>
+          <a:noFill/>
+        </p:spPr>
+        <p:txBody>
+          <a:bodyPr wrap="square" anchor="t" lIns="0" rIns="0" tIns="0" bIns="0">
+            <a:spAutoFit/>
+          </a:bodyPr>
+          <a:lstStyle/>
+          <a:p>
+            <a:pPr algn="r"/>
+            <a:r>
+              <a:rPr sz="1150" b="0" i="0">
+                <a:solidFill>
+                  <a:srgbClr val="6B7480"/>
+                </a:solidFill>
+                <a:latin typeface="Inter"/>
+                <a:ea typeface="Inter"/>
+                <a:cs typeface="Inter"/>
+              </a:rPr>
+              <a:t>вес 2.5</a:t>
+            </a:r>
+          </a:p>
+        </p:txBody>
+      </p:sp>
+      <p:sp>
+        <p:nvSpPr>
+          <p:cNvPr id="36" name="Rectangle 35"/>
+          <p:cNvSpPr/>
+          <p:nvPr/>
+        </p:nvSpPr>
+        <p:spPr>
+          <a:xfrm>
+            <a:off x="5166360" y="5340096"/>
+            <a:ext cx="1417320" cy="118872"/>
+          </a:xfrm>
+          <a:prstGeom prst="rect">
+            <a:avLst/>
+          </a:prstGeom>
+          <a:solidFill>
+            <a:srgbClr val="D9DEE2"/>
+          </a:solidFill>
+          <a:ln>
+            <a:noFill/>
+          </a:ln>
+          <a:effectLst/>
+        </p:spPr>
+        <p:style>
+          <a:lnRef idx="1">
+            <a:schemeClr val="accent1"/>
+          </a:lnRef>
+          <a:fillRef idx="3">
+            <a:schemeClr val="accent1"/>
+          </a:fillRef>
+          <a:effectRef idx="2">
+            <a:schemeClr val="accent1"/>
+          </a:effectRef>
+          <a:fontRef idx="minor">
+            <a:schemeClr val="lt1"/>
+          </a:fontRef>
+        </p:style>
+        <p:txBody>
+          <a:bodyPr rtlCol="0" anchor="ctr"/>
+          <a:lstStyle/>
+          <a:p/>
+        </p:txBody>
+      </p:sp>
+      <p:sp>
+        <p:nvSpPr>
+          <p:cNvPr id="37" name="TextBox 36"/>
+          <p:cNvSpPr txBox="1"/>
+          <p:nvPr/>
+        </p:nvSpPr>
+        <p:spPr>
+          <a:xfrm>
+            <a:off x="6675120" y="5294376"/>
+            <a:ext cx="868680" cy="310896"/>
+          </a:xfrm>
+          <a:prstGeom prst="rect">
+            <a:avLst/>
+          </a:prstGeom>
+          <a:noFill/>
+        </p:spPr>
+        <p:txBody>
+          <a:bodyPr wrap="square" anchor="t" lIns="0" rIns="0" tIns="0" bIns="0">
+            <a:spAutoFit/>
+          </a:bodyPr>
+          <a:lstStyle/>
+          <a:p>
+            <a:pPr algn="r"/>
+            <a:r>
+              <a:rPr sz="1250" b="1" i="0">
+                <a:solidFill>
+                  <a:srgbClr val="202B3A"/>
+                </a:solidFill>
+                <a:latin typeface="Inter"/>
+                <a:ea typeface="Inter"/>
+                <a:cs typeface="Inter"/>
+              </a:rPr>
+              <a:t>0.0</a:t>
+            </a:r>
+          </a:p>
+        </p:txBody>
+      </p:sp>
+      <p:cxnSp>
+        <p:nvCxnSpPr>
+          <p:cNvPr id="38" name="Connector 37"/>
+          <p:cNvCxnSpPr/>
+          <p:nvPr/>
+        </p:nvCxnSpPr>
+        <p:spPr>
+          <a:xfrm>
+            <a:off x="777240" y="5870448"/>
+            <a:ext cx="6766560" cy="0"/>
+          </a:xfrm>
+          <a:prstGeom prst="line">
+            <a:avLst/>
+          </a:prstGeom>
+          <a:ln w="9525">
+            <a:solidFill>
+              <a:srgbClr val="D9DEE2"/>
+            </a:solidFill>
+          </a:ln>
+        </p:spPr>
+        <p:style>
+          <a:lnRef idx="2">
+            <a:schemeClr val="accent1"/>
+          </a:lnRef>
+          <a:fillRef idx="0">
+            <a:schemeClr val="accent1"/>
+          </a:fillRef>
+          <a:effectRef idx="1">
+            <a:schemeClr val="accent1"/>
+          </a:effectRef>
+          <a:fontRef idx="minor">
+            <a:schemeClr val="tx1"/>
+          </a:fontRef>
+        </p:style>
+      </p:cxnSp>
+      <p:sp>
+        <p:nvSpPr>
+          <p:cNvPr id="39" name="TextBox 38"/>
+          <p:cNvSpPr txBox="1"/>
+          <p:nvPr/>
+        </p:nvSpPr>
+        <p:spPr>
+          <a:xfrm>
+            <a:off x="777240" y="5998464"/>
+            <a:ext cx="6949440" cy="365760"/>
+          </a:xfrm>
+          <a:prstGeom prst="rect">
+            <a:avLst/>
+          </a:prstGeom>
+          <a:noFill/>
+        </p:spPr>
+        <p:txBody>
+          <a:bodyPr wrap="square" anchor="t" lIns="0" rIns="0" tIns="0" bIns="0">
+            <a:spAutoFit/>
+          </a:bodyPr>
+          <a:lstStyle/>
+          <a:p>
+            <a:pPr algn="l"/>
+            <a:r>
+              <a:rPr sz="1250" b="1">
+                <a:solidFill>
+                  <a:srgbClr val="202B3A"/>
+                </a:solidFill>
+                <a:latin typeface="Inter"/>
+                <a:ea typeface="Inter"/>
+                <a:cs typeface="Inter"/>
+              </a:rPr>
+              <a:t>Итог: </a:t>
+            </a:r>
+            <a:r>
+              <a:rPr sz="1250" b="0">
+                <a:solidFill>
+                  <a:srgbClr val="202B3A"/>
+                </a:solidFill>
+                <a:latin typeface="Inter"/>
+                <a:ea typeface="Inter"/>
+                <a:cs typeface="Inter"/>
+              </a:rPr>
+              <a:t>100 × 7.5 / 13 = 71.4 из 100. </a:t>
+            </a:r>
+            <a:r>
+              <a:rPr sz="1250" b="0">
+                <a:solidFill>
+                  <a:srgbClr val="6B7480"/>
+                </a:solidFill>
+                <a:latin typeface="Inter"/>
+                <a:ea typeface="Inter"/>
+                <a:cs typeface="Inter"/>
+              </a:rPr>
+              <a:t>Веса настраиваются аналитиком.</a:t>
+            </a:r>
+          </a:p>
+        </p:txBody>
+      </p:sp>
+      <p:sp>
+        <p:nvSpPr>
+          <p:cNvPr id="40" name="TextBox 39"/>
+          <p:cNvSpPr txBox="1"/>
+          <p:nvPr/>
+        </p:nvSpPr>
+        <p:spPr>
+          <a:xfrm>
+            <a:off x="8092440" y="2377440"/>
+            <a:ext cx="3337560" cy="320040"/>
+          </a:xfrm>
+          <a:prstGeom prst="rect">
+            <a:avLst/>
+          </a:prstGeom>
+          <a:noFill/>
+        </p:spPr>
+        <p:txBody>
+          <a:bodyPr wrap="square" anchor="t" lIns="0" rIns="0" tIns="0" bIns="0">
+            <a:spAutoFit/>
+          </a:bodyPr>
+          <a:lstStyle/>
+          <a:p>
+            <a:pPr algn="l"/>
+            <a:r>
+              <a:rPr sz="1100" b="1" i="0">
+                <a:solidFill>
+                  <a:srgbClr val="6B7480"/>
+                </a:solidFill>
+                <a:latin typeface="Inter"/>
+                <a:ea typeface="Inter"/>
+                <a:cs typeface="Inter"/>
+              </a:rPr>
+              <a:t>КАК ЭТО ЧИТАТЬ</a:t>
+            </a:r>
+          </a:p>
+        </p:txBody>
+      </p:sp>
+      <p:sp>
+        <p:nvSpPr>
+          <p:cNvPr id="41" name="Rectangle 40"/>
+          <p:cNvSpPr/>
+          <p:nvPr/>
+        </p:nvSpPr>
+        <p:spPr>
+          <a:xfrm>
+            <a:off x="8092440" y="2843784"/>
+            <a:ext cx="137160" cy="137160"/>
           </a:xfrm>
           <a:prstGeom prst="rect">
             <a:avLst/>
@@ -8702,14 +9176,14 @@
       </p:sp>
       <p:sp>
         <p:nvSpPr>
-          <p:cNvPr id="30" name="TextBox 29"/>
+          <p:cNvPr id="42" name="TextBox 41"/>
           <p:cNvSpPr txBox="1"/>
           <p:nvPr/>
         </p:nvSpPr>
         <p:spPr>
           <a:xfrm>
-            <a:off x="6675120" y="4453128"/>
-            <a:ext cx="868680" cy="310896"/>
+            <a:off x="8421624" y="2798064"/>
+            <a:ext cx="3008376" cy="1005840"/>
           </a:xfrm>
           <a:prstGeom prst="rect">
             <a:avLst/>
@@ -8722,9 +9196,13 @@
           </a:bodyPr>
           <a:lstStyle/>
           <a:p>
-            <a:pPr algn="r"/>
-            <a:r>
-              <a:rPr sz="1250" b="1" i="0">
+            <a:pPr algn="l">
+              <a:lnSpc>
+                <a:spcPct val="135000"/>
+              </a:lnSpc>
+            </a:pPr>
+            <a:r>
+              <a:rPr sz="1250" b="0" i="0">
                 <a:solidFill>
                   <a:srgbClr val="202B3A"/>
                 </a:solidFill>
@@ -8732,290 +9210,21 @@
                 <a:ea typeface="Inter"/>
                 <a:cs typeface="Inter"/>
               </a:rPr>
-              <a:t>2.0</a:t>
-            </a:r>
-          </a:p>
-        </p:txBody>
-      </p:sp>
-      <p:sp>
-        <p:nvSpPr>
-          <p:cNvPr id="31" name="TextBox 30"/>
-          <p:cNvSpPr txBox="1"/>
-          <p:nvPr/>
-        </p:nvSpPr>
-        <p:spPr>
-          <a:xfrm>
-            <a:off x="777240" y="4873752"/>
-            <a:ext cx="3035808" cy="310896"/>
-          </a:xfrm>
-          <a:prstGeom prst="rect">
-            <a:avLst/>
-          </a:prstGeom>
-          <a:noFill/>
-        </p:spPr>
-        <p:txBody>
-          <a:bodyPr wrap="square" anchor="t" lIns="0" rIns="0" tIns="0" bIns="0">
-            <a:spAutoFit/>
-          </a:bodyPr>
-          <a:lstStyle/>
-          <a:p>
-            <a:pPr algn="l"/>
-            <a:r>
-              <a:rPr sz="1200" b="1" i="0">
-                <a:solidFill>
-                  <a:srgbClr val="202B3A"/>
-                </a:solidFill>
-                <a:latin typeface="Inter"/>
-                <a:ea typeface="Inter"/>
-                <a:cs typeface="Inter"/>
-              </a:rPr>
-              <a:t>Услуга приостановлена</a:t>
-            </a:r>
-          </a:p>
-        </p:txBody>
-      </p:sp>
-      <p:sp>
-        <p:nvSpPr>
-          <p:cNvPr id="32" name="TextBox 31"/>
-          <p:cNvSpPr txBox="1"/>
-          <p:nvPr/>
-        </p:nvSpPr>
-        <p:spPr>
-          <a:xfrm>
-            <a:off x="3849624" y="4873752"/>
-            <a:ext cx="1170432" cy="310896"/>
-          </a:xfrm>
-          <a:prstGeom prst="rect">
-            <a:avLst/>
-          </a:prstGeom>
-          <a:noFill/>
-        </p:spPr>
-        <p:txBody>
-          <a:bodyPr wrap="square" anchor="t" lIns="0" rIns="0" tIns="0" bIns="0">
-            <a:spAutoFit/>
-          </a:bodyPr>
-          <a:lstStyle/>
-          <a:p>
-            <a:pPr algn="r"/>
-            <a:r>
-              <a:rPr sz="1150" b="0" i="0">
-                <a:solidFill>
-                  <a:srgbClr val="6B7480"/>
-                </a:solidFill>
-                <a:latin typeface="Inter"/>
-                <a:ea typeface="Inter"/>
-                <a:cs typeface="Inter"/>
-              </a:rPr>
-              <a:t>вес 2</a:t>
-            </a:r>
-          </a:p>
-        </p:txBody>
-      </p:sp>
-      <p:sp>
-        <p:nvSpPr>
-          <p:cNvPr id="33" name="Rectangle 32"/>
+              <a:t>Балл — сила наблюдаемых сигналов, не вероятность ухода в процентах.</a:t>
+            </a:r>
+          </a:p>
+        </p:txBody>
+      </p:sp>
+      <p:sp>
+        <p:nvSpPr>
+          <p:cNvPr id="43" name="Rectangle 42"/>
           <p:cNvSpPr/>
           <p:nvPr/>
         </p:nvSpPr>
         <p:spPr>
           <a:xfrm>
-            <a:off x="5166360" y="4919472"/>
-            <a:ext cx="1417320" cy="118872"/>
-          </a:xfrm>
-          <a:prstGeom prst="rect">
-            <a:avLst/>
-          </a:prstGeom>
-          <a:solidFill>
-            <a:srgbClr val="D9DEE2"/>
-          </a:solidFill>
-          <a:ln>
-            <a:noFill/>
-          </a:ln>
-          <a:effectLst/>
-        </p:spPr>
-        <p:style>
-          <a:lnRef idx="1">
-            <a:schemeClr val="accent1"/>
-          </a:lnRef>
-          <a:fillRef idx="3">
-            <a:schemeClr val="accent1"/>
-          </a:fillRef>
-          <a:effectRef idx="2">
-            <a:schemeClr val="accent1"/>
-          </a:effectRef>
-          <a:fontRef idx="minor">
-            <a:schemeClr val="lt1"/>
-          </a:fontRef>
-        </p:style>
-        <p:txBody>
-          <a:bodyPr rtlCol="0" anchor="ctr"/>
-          <a:lstStyle/>
-          <a:p/>
-        </p:txBody>
-      </p:sp>
-      <p:sp>
-        <p:nvSpPr>
-          <p:cNvPr id="34" name="TextBox 33"/>
-          <p:cNvSpPr txBox="1"/>
-          <p:nvPr/>
-        </p:nvSpPr>
-        <p:spPr>
-          <a:xfrm>
-            <a:off x="6675120" y="4873752"/>
-            <a:ext cx="868680" cy="310896"/>
-          </a:xfrm>
-          <a:prstGeom prst="rect">
-            <a:avLst/>
-          </a:prstGeom>
-          <a:noFill/>
-        </p:spPr>
-        <p:txBody>
-          <a:bodyPr wrap="square" anchor="t" lIns="0" rIns="0" tIns="0" bIns="0">
-            <a:spAutoFit/>
-          </a:bodyPr>
-          <a:lstStyle/>
-          <a:p>
-            <a:pPr algn="r"/>
-            <a:r>
-              <a:rPr sz="1250" b="1" i="0">
-                <a:solidFill>
-                  <a:srgbClr val="202B3A"/>
-                </a:solidFill>
-                <a:latin typeface="Inter"/>
-                <a:ea typeface="Inter"/>
-                <a:cs typeface="Inter"/>
-              </a:rPr>
-              <a:t>0.0</a:t>
-            </a:r>
-          </a:p>
-        </p:txBody>
-      </p:sp>
-      <p:sp>
-        <p:nvSpPr>
-          <p:cNvPr id="35" name="TextBox 34"/>
-          <p:cNvSpPr txBox="1"/>
-          <p:nvPr/>
-        </p:nvSpPr>
-        <p:spPr>
-          <a:xfrm>
-            <a:off x="777240" y="5294376"/>
-            <a:ext cx="3035808" cy="310896"/>
-          </a:xfrm>
-          <a:prstGeom prst="rect">
-            <a:avLst/>
-          </a:prstGeom>
-          <a:noFill/>
-        </p:spPr>
-        <p:txBody>
-          <a:bodyPr wrap="square" anchor="t" lIns="0" rIns="0" tIns="0" bIns="0">
-            <a:spAutoFit/>
-          </a:bodyPr>
-          <a:lstStyle/>
-          <a:p>
-            <a:pPr algn="l"/>
-            <a:r>
-              <a:rPr sz="1200" b="1" i="0">
-                <a:solidFill>
-                  <a:srgbClr val="202B3A"/>
-                </a:solidFill>
-                <a:latin typeface="Inter"/>
-                <a:ea typeface="Inter"/>
-                <a:cs typeface="Inter"/>
-              </a:rPr>
-              <a:t>Доля неуспешных продлений</a:t>
-            </a:r>
-          </a:p>
-        </p:txBody>
-      </p:sp>
-      <p:sp>
-        <p:nvSpPr>
-          <p:cNvPr id="36" name="TextBox 35"/>
-          <p:cNvSpPr txBox="1"/>
-          <p:nvPr/>
-        </p:nvSpPr>
-        <p:spPr>
-          <a:xfrm>
-            <a:off x="3849624" y="5294376"/>
-            <a:ext cx="1170432" cy="310896"/>
-          </a:xfrm>
-          <a:prstGeom prst="rect">
-            <a:avLst/>
-          </a:prstGeom>
-          <a:noFill/>
-        </p:spPr>
-        <p:txBody>
-          <a:bodyPr wrap="square" anchor="t" lIns="0" rIns="0" tIns="0" bIns="0">
-            <a:spAutoFit/>
-          </a:bodyPr>
-          <a:lstStyle/>
-          <a:p>
-            <a:pPr algn="r"/>
-            <a:r>
-              <a:rPr sz="1150" b="0" i="0">
-                <a:solidFill>
-                  <a:srgbClr val="6B7480"/>
-                </a:solidFill>
-                <a:latin typeface="Inter"/>
-                <a:ea typeface="Inter"/>
-                <a:cs typeface="Inter"/>
-              </a:rPr>
-              <a:t>вес 1.5</a:t>
-            </a:r>
-          </a:p>
-        </p:txBody>
-      </p:sp>
-      <p:sp>
-        <p:nvSpPr>
-          <p:cNvPr id="37" name="Rectangle 36"/>
-          <p:cNvSpPr/>
-          <p:nvPr/>
-        </p:nvSpPr>
-        <p:spPr>
-          <a:xfrm>
-            <a:off x="5166360" y="5340096"/>
-            <a:ext cx="1417320" cy="118872"/>
-          </a:xfrm>
-          <a:prstGeom prst="rect">
-            <a:avLst/>
-          </a:prstGeom>
-          <a:solidFill>
-            <a:srgbClr val="D9DEE2"/>
-          </a:solidFill>
-          <a:ln>
-            <a:noFill/>
-          </a:ln>
-          <a:effectLst/>
-        </p:spPr>
-        <p:style>
-          <a:lnRef idx="1">
-            <a:schemeClr val="accent1"/>
-          </a:lnRef>
-          <a:fillRef idx="3">
-            <a:schemeClr val="accent1"/>
-          </a:fillRef>
-          <a:effectRef idx="2">
-            <a:schemeClr val="accent1"/>
-          </a:effectRef>
-          <a:fontRef idx="minor">
-            <a:schemeClr val="lt1"/>
-          </a:fontRef>
-        </p:style>
-        <p:txBody>
-          <a:bodyPr rtlCol="0" anchor="ctr"/>
-          <a:lstStyle/>
-          <a:p/>
-        </p:txBody>
-      </p:sp>
-      <p:sp>
-        <p:nvSpPr>
-          <p:cNvPr id="38" name="Rectangle 37"/>
-          <p:cNvSpPr/>
-          <p:nvPr/>
-        </p:nvSpPr>
-        <p:spPr>
-          <a:xfrm>
-            <a:off x="5166360" y="5340096"/>
-            <a:ext cx="708660" cy="118872"/>
+            <a:off x="8092440" y="3904488"/>
+            <a:ext cx="137160" cy="137160"/>
           </a:xfrm>
           <a:prstGeom prst="rect">
             <a:avLst/>
@@ -9050,223 +9259,13 @@
       </p:sp>
       <p:sp>
         <p:nvSpPr>
-          <p:cNvPr id="39" name="TextBox 38"/>
-          <p:cNvSpPr txBox="1"/>
-          <p:nvPr/>
-        </p:nvSpPr>
-        <p:spPr>
-          <a:xfrm>
-            <a:off x="6675120" y="5294376"/>
-            <a:ext cx="868680" cy="310896"/>
-          </a:xfrm>
-          <a:prstGeom prst="rect">
-            <a:avLst/>
-          </a:prstGeom>
-          <a:noFill/>
-        </p:spPr>
-        <p:txBody>
-          <a:bodyPr wrap="square" anchor="t" lIns="0" rIns="0" tIns="0" bIns="0">
-            <a:spAutoFit/>
-          </a:bodyPr>
-          <a:lstStyle/>
-          <a:p>
-            <a:pPr algn="r"/>
-            <a:r>
-              <a:rPr sz="1250" b="1" i="0">
-                <a:solidFill>
-                  <a:srgbClr val="202B3A"/>
-                </a:solidFill>
-                <a:latin typeface="Inter"/>
-                <a:ea typeface="Inter"/>
-                <a:cs typeface="Inter"/>
-              </a:rPr>
-              <a:t>1.5</a:t>
-            </a:r>
-          </a:p>
-        </p:txBody>
-      </p:sp>
-      <p:cxnSp>
-        <p:nvCxnSpPr>
-          <p:cNvPr id="40" name="Connector 39"/>
-          <p:cNvCxnSpPr/>
-          <p:nvPr/>
-        </p:nvCxnSpPr>
-        <p:spPr>
-          <a:xfrm>
-            <a:off x="777240" y="5870448"/>
-            <a:ext cx="6766560" cy="0"/>
-          </a:xfrm>
-          <a:prstGeom prst="line">
-            <a:avLst/>
-          </a:prstGeom>
-          <a:ln w="9525">
-            <a:solidFill>
-              <a:srgbClr val="D9DEE2"/>
-            </a:solidFill>
-          </a:ln>
-        </p:spPr>
-        <p:style>
-          <a:lnRef idx="2">
-            <a:schemeClr val="accent1"/>
-          </a:lnRef>
-          <a:fillRef idx="0">
-            <a:schemeClr val="accent1"/>
-          </a:fillRef>
-          <a:effectRef idx="1">
-            <a:schemeClr val="accent1"/>
-          </a:effectRef>
-          <a:fontRef idx="minor">
-            <a:schemeClr val="tx1"/>
-          </a:fontRef>
-        </p:style>
-      </p:cxnSp>
-      <p:sp>
-        <p:nvSpPr>
-          <p:cNvPr id="41" name="TextBox 40"/>
-          <p:cNvSpPr txBox="1"/>
-          <p:nvPr/>
-        </p:nvSpPr>
-        <p:spPr>
-          <a:xfrm>
-            <a:off x="777240" y="5998464"/>
-            <a:ext cx="6949440" cy="365760"/>
-          </a:xfrm>
-          <a:prstGeom prst="rect">
-            <a:avLst/>
-          </a:prstGeom>
-          <a:noFill/>
-        </p:spPr>
-        <p:txBody>
-          <a:bodyPr wrap="square" anchor="t" lIns="0" rIns="0" tIns="0" bIns="0">
-            <a:spAutoFit/>
-          </a:bodyPr>
-          <a:lstStyle/>
-          <a:p>
-            <a:pPr algn="l"/>
-            <a:r>
-              <a:rPr sz="1250" b="1">
-                <a:solidFill>
-                  <a:srgbClr val="202B3A"/>
-                </a:solidFill>
-                <a:latin typeface="Inter"/>
-                <a:ea typeface="Inter"/>
-                <a:cs typeface="Inter"/>
-              </a:rPr>
-              <a:t>Итог: </a:t>
-            </a:r>
-            <a:r>
-              <a:rPr sz="1250" b="0">
-                <a:solidFill>
-                  <a:srgbClr val="202B3A"/>
-                </a:solidFill>
-                <a:latin typeface="Inter"/>
-                <a:ea typeface="Inter"/>
-                <a:cs typeface="Inter"/>
-              </a:rPr>
-              <a:t>100 × 11 / 15 = 73.3 из 100. </a:t>
-            </a:r>
-            <a:r>
-              <a:rPr sz="1250" b="0">
-                <a:solidFill>
-                  <a:srgbClr val="6B7480"/>
-                </a:solidFill>
-                <a:latin typeface="Inter"/>
-                <a:ea typeface="Inter"/>
-                <a:cs typeface="Inter"/>
-              </a:rPr>
-              <a:t>Веса настраиваются аналитиком.</a:t>
-            </a:r>
-          </a:p>
-        </p:txBody>
-      </p:sp>
-      <p:sp>
-        <p:nvSpPr>
-          <p:cNvPr id="42" name="TextBox 41"/>
-          <p:cNvSpPr txBox="1"/>
-          <p:nvPr/>
-        </p:nvSpPr>
-        <p:spPr>
-          <a:xfrm>
-            <a:off x="8092440" y="2377440"/>
-            <a:ext cx="3337560" cy="320040"/>
-          </a:xfrm>
-          <a:prstGeom prst="rect">
-            <a:avLst/>
-          </a:prstGeom>
-          <a:noFill/>
-        </p:spPr>
-        <p:txBody>
-          <a:bodyPr wrap="square" anchor="t" lIns="0" rIns="0" tIns="0" bIns="0">
-            <a:spAutoFit/>
-          </a:bodyPr>
-          <a:lstStyle/>
-          <a:p>
-            <a:pPr algn="l"/>
-            <a:r>
-              <a:rPr sz="1100" b="1" i="0">
-                <a:solidFill>
-                  <a:srgbClr val="6B7480"/>
-                </a:solidFill>
-                <a:latin typeface="Inter"/>
-                <a:ea typeface="Inter"/>
-                <a:cs typeface="Inter"/>
-              </a:rPr>
-              <a:t>КАК ЭТО ЧИТАТЬ</a:t>
-            </a:r>
-          </a:p>
-        </p:txBody>
-      </p:sp>
-      <p:sp>
-        <p:nvSpPr>
-          <p:cNvPr id="43" name="Rectangle 42"/>
-          <p:cNvSpPr/>
-          <p:nvPr/>
-        </p:nvSpPr>
-        <p:spPr>
-          <a:xfrm>
-            <a:off x="8092440" y="2843784"/>
-            <a:ext cx="137160" cy="137160"/>
-          </a:xfrm>
-          <a:prstGeom prst="rect">
-            <a:avLst/>
-          </a:prstGeom>
-          <a:solidFill>
-            <a:srgbClr val="EF634D"/>
-          </a:solidFill>
-          <a:ln>
-            <a:noFill/>
-          </a:ln>
-          <a:effectLst/>
-        </p:spPr>
-        <p:style>
-          <a:lnRef idx="1">
-            <a:schemeClr val="accent1"/>
-          </a:lnRef>
-          <a:fillRef idx="3">
-            <a:schemeClr val="accent1"/>
-          </a:fillRef>
-          <a:effectRef idx="2">
-            <a:schemeClr val="accent1"/>
-          </a:effectRef>
-          <a:fontRef idx="minor">
-            <a:schemeClr val="lt1"/>
-          </a:fontRef>
-        </p:style>
-        <p:txBody>
-          <a:bodyPr rtlCol="0" anchor="ctr"/>
-          <a:lstStyle/>
-          <a:p/>
-        </p:txBody>
-      </p:sp>
-      <p:sp>
-        <p:nvSpPr>
           <p:cNvPr id="44" name="TextBox 43"/>
           <p:cNvSpPr txBox="1"/>
           <p:nvPr/>
         </p:nvSpPr>
         <p:spPr>
           <a:xfrm>
-            <a:off x="8421624" y="2798064"/>
+            <a:off x="8421624" y="3858768"/>
             <a:ext cx="3008376" cy="1005840"/>
           </a:xfrm>
           <a:prstGeom prst="rect">
@@ -9294,7 +9293,7 @@
                 <a:ea typeface="Inter"/>
                 <a:cs typeface="Inter"/>
               </a:rPr>
-              <a:t>Балл — сила наблюдаемых сигналов, не вероятность ухода в процентах.</a:t>
+              <a:t>Факторы не доказывают причину оттока: модель rule-based, без обучения.</a:t>
             </a:r>
           </a:p>
         </p:txBody>
@@ -9302,89 +9301,6 @@
       <p:sp>
         <p:nvSpPr>
           <p:cNvPr id="45" name="Rectangle 44"/>
-          <p:cNvSpPr/>
-          <p:nvPr/>
-        </p:nvSpPr>
-        <p:spPr>
-          <a:xfrm>
-            <a:off x="8092440" y="3904488"/>
-            <a:ext cx="137160" cy="137160"/>
-          </a:xfrm>
-          <a:prstGeom prst="rect">
-            <a:avLst/>
-          </a:prstGeom>
-          <a:solidFill>
-            <a:srgbClr val="EF634D"/>
-          </a:solidFill>
-          <a:ln>
-            <a:noFill/>
-          </a:ln>
-          <a:effectLst/>
-        </p:spPr>
-        <p:style>
-          <a:lnRef idx="1">
-            <a:schemeClr val="accent1"/>
-          </a:lnRef>
-          <a:fillRef idx="3">
-            <a:schemeClr val="accent1"/>
-          </a:fillRef>
-          <a:effectRef idx="2">
-            <a:schemeClr val="accent1"/>
-          </a:effectRef>
-          <a:fontRef idx="minor">
-            <a:schemeClr val="lt1"/>
-          </a:fontRef>
-        </p:style>
-        <p:txBody>
-          <a:bodyPr rtlCol="0" anchor="ctr"/>
-          <a:lstStyle/>
-          <a:p/>
-        </p:txBody>
-      </p:sp>
-      <p:sp>
-        <p:nvSpPr>
-          <p:cNvPr id="46" name="TextBox 45"/>
-          <p:cNvSpPr txBox="1"/>
-          <p:nvPr/>
-        </p:nvSpPr>
-        <p:spPr>
-          <a:xfrm>
-            <a:off x="8421624" y="3858768"/>
-            <a:ext cx="3008376" cy="1005840"/>
-          </a:xfrm>
-          <a:prstGeom prst="rect">
-            <a:avLst/>
-          </a:prstGeom>
-          <a:noFill/>
-        </p:spPr>
-        <p:txBody>
-          <a:bodyPr wrap="square" anchor="t" lIns="0" rIns="0" tIns="0" bIns="0">
-            <a:spAutoFit/>
-          </a:bodyPr>
-          <a:lstStyle/>
-          <a:p>
-            <a:pPr algn="l">
-              <a:lnSpc>
-                <a:spcPct val="135000"/>
-              </a:lnSpc>
-            </a:pPr>
-            <a:r>
-              <a:rPr sz="1250" b="0" i="0">
-                <a:solidFill>
-                  <a:srgbClr val="202B3A"/>
-                </a:solidFill>
-                <a:latin typeface="Inter"/>
-                <a:ea typeface="Inter"/>
-                <a:cs typeface="Inter"/>
-              </a:rPr>
-              <a:t>Факторы не доказывают причину оттока: модель rule-based, без обучения.</a:t>
-            </a:r>
-          </a:p>
-        </p:txBody>
-      </p:sp>
-      <p:sp>
-        <p:nvSpPr>
-          <p:cNvPr id="47" name="Rectangle 46"/>
           <p:cNvSpPr/>
           <p:nvPr/>
         </p:nvSpPr>
@@ -9426,7 +9342,7 @@
       </p:sp>
       <p:sp>
         <p:nvSpPr>
-          <p:cNvPr id="48" name="TextBox 47"/>
+          <p:cNvPr id="46" name="TextBox 45"/>
           <p:cNvSpPr txBox="1"/>
           <p:nvPr/>
         </p:nvSpPr>
@@ -9467,7 +9383,7 @@
       </p:sp>
       <p:sp>
         <p:nvSpPr>
-          <p:cNvPr id="49" name="TextBox 48"/>
+          <p:cNvPr id="47" name="TextBox 46"/>
           <p:cNvSpPr txBox="1"/>
           <p:nvPr/>
         </p:nvSpPr>
@@ -9735,7 +9651,7 @@
                 <a:ea typeface="Inter"/>
                 <a:cs typeface="Inter"/>
               </a:rPr>
-              <a:t>5,74 €</a:t>
+              <a:t>5,80 €</a:t>
             </a:r>
           </a:p>
           <a:p>
@@ -11677,7 +11593,7 @@
                 <a:ea typeface="Inter"/>
                 <a:cs typeface="Inter"/>
               </a:rPr>
-              <a:t>73.3</a:t>
+              <a:t>71.4</a:t>
             </a:r>
             <a:r>
               <a:rPr sz="4000" b="0">
@@ -11699,7 +11615,7 @@
                 <a:ea typeface="Inter"/>
                 <a:cs typeface="Inter"/>
               </a:rPr>
-              <a:t>81.0</a:t>
+              <a:t>81.8</a:t>
             </a:r>
           </a:p>
         </p:txBody>
@@ -11773,7 +11689,7 @@
                 <a:ea typeface="Inter"/>
                 <a:cs typeface="Inter"/>
               </a:rPr>
-              <a:t>2</a:t>
+              <a:t>3</a:t>
             </a:r>
             <a:r>
               <a:rPr sz="1900" b="0">
@@ -11869,7 +11785,7 @@
                 <a:ea typeface="Inter"/>
                 <a:cs typeface="Inter"/>
               </a:rPr>
-              <a:t>4</a:t>
+              <a:t>3</a:t>
             </a:r>
             <a:r>
               <a:rPr sz="1900" b="0">
@@ -11965,7 +11881,7 @@
                 <a:ea typeface="Inter"/>
                 <a:cs typeface="Inter"/>
               </a:rPr>
-              <a:t>5,74 €</a:t>
+              <a:t>5,80 €</a:t>
             </a:r>
             <a:r>
               <a:rPr sz="1900" b="0">
@@ -11987,7 +11903,7 @@
                 <a:ea typeface="Inter"/>
                 <a:cs typeface="Inter"/>
               </a:rPr>
-              <a:t>7,48 €</a:t>
+              <a:t>7,72 €</a:t>
             </a:r>
           </a:p>
         </p:txBody>

</xml_diff>

<commit_message>
Refresh defence decks and docs to match the verified product state
Re-capture deck screenshots against the live build at 1100px so the
screenshots' aspect ratio is reproduced from the real images instead of
hardcoded divisors, and rebuild both decks from the corrected figures.

Also correct what the demo materials claim about the ranking: customers
#5 and #10 tie at 71,4, so #10 is not the unique maximum. Fix the
remaining stale numbers (73,3 -> 71,4, 5,74 -> 5,80, 15,0 -> 13,0), the
demo password (demo123 -> aeza-demo-password) and the runbook paths.

Co-authored-by: openhands <openhands@all-hands.dev>
</commit_message>
<xml_diff>
--- a/aeza_hackathon_osen_2026.pptx
+++ b/aeza_hackathon_osen_2026.pptx
@@ -147,9 +147,9 @@
           </c:spPr>
           <c:cat>
             <c:strRef>
-              <c:f>Sheet1!$A$2:$A$8</c:f>
+              <c:f>Sheet1!$A$2:$A$6</c:f>
               <c:strCache>
-                <c:ptCount val="7"/>
+                <c:ptCount val="5"/>
                 <c:pt idx="0">
                   <c:v>Близость даты окончания · 3,0</c:v>
                 </c:pt>
@@ -160,26 +160,20 @@
                   <c:v>Автопродление отключено · 2,0</c:v>
                 </c:pt>
                 <c:pt idx="3">
-                  <c:v>Неуспешные продления · 2,0</c:v>
+                  <c:v>Недостаточно средств · 0,0</c:v>
                 </c:pt>
                 <c:pt idx="4">
-                  <c:v>Доля неуспешных продлений · 1,5</c:v>
-                </c:pt>
-                <c:pt idx="5">
-                  <c:v>Недостаточно средств · 2,0</c:v>
-                </c:pt>
-                <c:pt idx="6">
-                  <c:v>Услуга приостановлена · 2,0</c:v>
+                  <c:v>Услуга приостановлена · 0,0</c:v>
                 </c:pt>
               </c:strCache>
             </c:strRef>
           </c:cat>
           <c:val>
             <c:numRef>
-              <c:f>Sheet1!$B$2:$B$8</c:f>
+              <c:f>Sheet1!$B$2:$B$6</c:f>
               <c:numCache>
                 <c:formatCode>General</c:formatCode>
-                <c:ptCount val="7"/>
+                <c:ptCount val="5"/>
                 <c:pt idx="0">
                   <c:v>3.0</c:v>
                 </c:pt>
@@ -190,15 +184,9 @@
                   <c:v>2.0</c:v>
                 </c:pt>
                 <c:pt idx="3">
-                  <c:v>2.0</c:v>
+                  <c:v>0.0</c:v>
                 </c:pt>
                 <c:pt idx="4">
-                  <c:v>1.5</c:v>
-                </c:pt>
-                <c:pt idx="5">
-                  <c:v>0.0</c:v>
-                </c:pt>
-                <c:pt idx="6">
                   <c:v>0.0</c:v>
                 </c:pt>
               </c:numCache>
@@ -927,7 +915,7 @@
           </a:p>
           <a:p>
             <a:r>
-              <a:t>по 6 есть неуспешные продления и 6 услуг приостановлены. Каждый сигнал по</a:t>
+              <a:t>6 услуг приостановлены и 6 ждут продления. Каждый сигнал по</a:t>
             </a:r>
           </a:p>
           <a:p>
@@ -1064,7 +1052,12 @@
           </a:p>
           <a:p>
             <a:r>
-              <a:t>строку user-0010@example.test — верхняя, балл 73,3), справа сводные метрики и блок</a:t>
+              <a:t>строку user-0010@example.test — балл 71,4, верхняя группа риска), справа сводные</a:t>
+            </a:r>
+          </a:p>
+          <a:p>
+            <a:r>
+              <a:t>метрики и блок</a:t>
             </a:r>
           </a:p>
           <a:p>
@@ -1159,17 +1152,22 @@
           </a:p>
           <a:p>
             <a:r>
-              <a:t>«Открываем список клиентов — он уже отсортирован по риску. Верхняя строка:</a:t>
-            </a:r>
-          </a:p>
-          <a:p>
-            <a:r>
-              <a:t>клиент #10, балл 73,3 из 100, категория «высокий». Выбираем его не случайно —</a:t>
-            </a:r>
-          </a:p>
-          <a:p>
-            <a:r>
-              <a:t>это максимум по списку.</a:t>
+              <a:t>«Открываем список клиентов — он уже отсортирован по риску. Сверху двое с</a:t>
+            </a:r>
+          </a:p>
+          <a:p>
+            <a:r>
+              <a:t>одинаковым баллом 71,4: клиент #5 и клиент #10. Берём #10 — он показывает</a:t>
+            </a:r>
+          </a:p>
+          <a:p>
+            <a:r>
+              <a:t>то же правило клиентского балла на двух услугах сразу. Максимум по списку</a:t>
+            </a:r>
+          </a:p>
+          <a:p>
+            <a:r>
+              <a:t>именно 71,4, и ни один клиент не поднялся выше.</a:t>
             </a:r>
           </a:p>
           <a:p>
@@ -1189,12 +1187,12 @@
           </a:p>
           <a:p>
             <a:r>
-              <a:t>Причины: услуга просрочена на 35 дней, два продления из двух не выполнены,</a:t>
-            </a:r>
-          </a:p>
-          <a:p>
-            <a:r>
-              <a:t>автопродление выключено.»</a:t>
+              <a:t>Причины: услуга просрочена на 35 дней, ждёт продления, автопродление выключено.</a:t>
+            </a:r>
+          </a:p>
+          <a:p>
+            <a:r>
+              <a:t>Три причины — это ровно те три фактора, что дали вклад в балл.»</a:t>
             </a:r>
           </a:p>
           <a:p/>
@@ -1205,12 +1203,17 @@
           </a:p>
           <a:p>
             <a:r>
-              <a:t>Возможный вопрос: «Почему балл клиента 73,3, а не среднее по услугам?» —</a:t>
+              <a:t>Возможный вопрос: «Почему балл клиента 71,4, а не среднее по услугам?» —</a:t>
             </a:r>
           </a:p>
           <a:p>
             <a:r>
               <a:t>Правило продукта: балл клиента — максимум по услугам, пригодным для прогноза.</a:t>
+            </a:r>
+          </a:p>
+          <a:p>
+            <a:r>
+              <a:t>У #10 это видно наглядно: две услуги по 71,4 и одна 52,4 — берётся максимум.</a:t>
             </a:r>
           </a:p>
           <a:p>
@@ -1300,12 +1303,12 @@
           </a:p>
           <a:p>
             <a:r>
-              <a:t>сумму вес×значение, делить на сумму весов. По этой услуге сумма вкладов 11 из 15 —</a:t>
-            </a:r>
-          </a:p>
-          <a:p>
-            <a:r>
-              <a:t>отсюда 73,3.</a:t>
+              <a:t>сумму вес×значение, делить на сумму весов. По этой услуге сумма вкладов 7,5 из 10,5 —</a:t>
+            </a:r>
+          </a:p>
+          <a:p>
+            <a:r>
+              <a:t>отсюда 71,4.</a:t>
             </a:r>
           </a:p>
           <a:p>
@@ -1315,12 +1318,22 @@
           </a:p>
           <a:p>
             <a:r>
-              <a:t>автопродление и неуспешные продления — по 2,0.</a:t>
-            </a:r>
-          </a:p>
-          <a:p>
-            <a:r>
-              <a:t>Два фактора дали ноль: баланса хватает на продление, услуга не приостановлена.</a:t>
+              <a:t>автопродление отключено — 2,0.</a:t>
+            </a:r>
+          </a:p>
+          <a:p>
+            <a:r>
+              <a:t>Остальные четыре фактора дали ноль: баланса хватает на продление, услуга не</a:t>
+            </a:r>
+          </a:p>
+          <a:p>
+            <a:r>
+              <a:t>приостановлена, а попыток продления за 90 дней нет, поэтому доля неуспешных</a:t>
+            </a:r>
+          </a:p>
+          <a:p>
+            <a:r>
+              <a:t>не определена и в знаменатель не входит.</a:t>
             </a:r>
           </a:p>
           <a:p>
@@ -1431,7 +1444,7 @@
           </a:p>
           <a:p>
             <a:r>
-              <a:t>«Здесь важно не сложить несопоставимое. У клиента #10 балл высокий — 73,3,</a:t>
+              <a:t>«Здесь важно не сложить несопоставимое. У клиента #10 балл высокий — 71,4,</a:t>
             </a:r>
           </a:p>
           <a:p>
@@ -1582,12 +1595,17 @@
           </a:p>
           <a:p>
             <a:r>
-              <a:t>Смотрите, что произошло. Балл клиента #10: 73,3 → 81,0. Клиентов высокого риска:</a:t>
-            </a:r>
-          </a:p>
-          <a:p>
-            <a:r>
-              <a:t>2 → 3, среднего: 4 → 3. Выручка под риском: 5,74 → 7,48 €.</a:t>
+              <a:t>Смотрите, что произошло. Балл клиента #10: 71,4 → 81,8. Услуг высокого риска:</a:t>
+            </a:r>
+          </a:p>
+          <a:p>
+            <a:r>
+              <a:t>4 → 7. Выручка под риском: 5,80 → 7,72 €. Категории клиентов при этом не сдвинулись —</a:t>
+            </a:r>
+          </a:p>
+          <a:p>
+            <a:r>
+              <a:t>это тоже честный результат, и его стоит показать.</a:t>
             </a:r>
           </a:p>
           <a:p>
@@ -1608,12 +1626,17 @@
           </a:p>
           <a:p>
             <a:r>
-              <a:t>обновляется на месте, без перезагрузки: 2 → 3 высокого, 4 → 3 среднего, 5,74 → 7,48 €,</a:t>
-            </a:r>
-          </a:p>
-          <a:p>
-            <a:r>
-              <a:t>сумма весов 15,0 → 21,0. Затем открыть карточку клиента #10 (балл 81,0) и вернуться</a:t>
+              <a:t>обновляется на месте, без перезагрузки: услуг высокого риска 4 → 7, выручка</a:t>
+            </a:r>
+          </a:p>
+          <a:p>
+            <a:r>
+              <a:t>под риском 5,80 → 7,72 €, сумма весов 13,0 → 19,0. Затем открыть карточку клиента #10</a:t>
+            </a:r>
+          </a:p>
+          <a:p>
+            <a:r>
+              <a:t>(балл 81,8) и вернуться</a:t>
             </a:r>
           </a:p>
           <a:p>
@@ -8715,7 +8738,7 @@
                 <a:cs typeface="Manrope"/>
                 <a:ea typeface="Manrope"/>
               </a:rPr>
-              <a:t>неуспешные продления</a:t>
+              <a:t>услуга приостановлена</a:t>
             </a:r>
           </a:p>
         </p:txBody>
@@ -8853,7 +8876,7 @@
                 <a:cs typeface="Manrope"/>
                 <a:ea typeface="Manrope"/>
               </a:rPr>
-              <a:t>услуга приостановлена</a:t>
+              <a:t>ожидание продления</a:t>
             </a:r>
           </a:p>
         </p:txBody>
@@ -9892,7 +9915,7 @@
         <p:spPr>
           <a:xfrm>
             <a:off x="626364" y="3012948"/>
-            <a:ext cx="6556248" cy="2418059"/>
+            <a:ext cx="6556248" cy="2713637"/>
           </a:xfrm>
           <a:prstGeom prst="rect">
             <a:avLst/>
@@ -9946,7 +9969,7 @@
         <p:spPr>
           <a:xfrm>
             <a:off x="658368" y="3044952"/>
-            <a:ext cx="6487678" cy="2354051"/>
+            <a:ext cx="6492240" cy="2649629"/>
           </a:xfrm>
           <a:prstGeom prst="rect">
             <a:avLst/>
@@ -9961,7 +9984,7 @@
         </p:nvSpPr>
         <p:spPr>
           <a:xfrm>
-            <a:off x="658368" y="5508731"/>
+            <a:off x="658368" y="5804309"/>
             <a:ext cx="6492240" cy="180848"/>
           </a:xfrm>
           <a:prstGeom prst="rect">
@@ -10056,7 +10079,7 @@
         <p:spPr>
           <a:xfrm>
             <a:off x="7392924" y="3012948"/>
-            <a:ext cx="4172407" cy="1346239"/>
+            <a:ext cx="4172407" cy="1350834"/>
           </a:xfrm>
           <a:prstGeom prst="rect">
             <a:avLst/>
@@ -10110,7 +10133,7 @@
         <p:spPr>
           <a:xfrm>
             <a:off x="7424928" y="3044952"/>
-            <a:ext cx="4093728" cy="1282231"/>
+            <a:ext cx="4108399" cy="1286826"/>
           </a:xfrm>
           <a:prstGeom prst="rect">
             <a:avLst/>
@@ -10125,8 +10148,8 @@
         </p:nvSpPr>
         <p:spPr>
           <a:xfrm>
-            <a:off x="7392924" y="4496347"/>
-            <a:ext cx="4172407" cy="1297724"/>
+            <a:off x="7392924" y="4500942"/>
+            <a:ext cx="4172407" cy="1173747"/>
           </a:xfrm>
           <a:prstGeom prst="rect">
             <a:avLst/>
@@ -10179,8 +10202,8 @@
         </p:blipFill>
         <p:spPr>
           <a:xfrm>
-            <a:off x="7424928" y="4528351"/>
-            <a:ext cx="4101909" cy="1233716"/>
+            <a:off x="7424928" y="4532946"/>
+            <a:ext cx="4108399" cy="1109739"/>
           </a:xfrm>
           <a:prstGeom prst="rect">
             <a:avLst/>
@@ -10195,7 +10218,7 @@
         </p:nvSpPr>
         <p:spPr>
           <a:xfrm>
-            <a:off x="7424928" y="5871795"/>
+            <a:off x="7424928" y="5752413"/>
             <a:ext cx="4108399" cy="343408"/>
           </a:xfrm>
           <a:prstGeom prst="rect">
@@ -10409,7 +10432,7 @@
                 <a:cs typeface="Manrope"/>
                 <a:ea typeface="Manrope"/>
               </a:rPr>
-              <a:t>Клиент #10 — высокий риск, 73,3 из 100</a:t>
+              <a:t>Клиент #10 — высокий риск, 71,4 из 100</a:t>
             </a:r>
           </a:p>
         </p:txBody>
@@ -10456,7 +10479,7 @@
                 <a:cs typeface="Manrope"/>
                 <a:ea typeface="Manrope"/>
               </a:rPr>
-              <a:t>Верхняя строка списка, отсортированного по риску по убыванию. Слева — реальные поля снимка, справа — тот же</a:t>
+              <a:t>Список отсортирован по риску по убыванию. Балл 71,4 делят клиенты #5 и #10 — берём #10, он выше по номеру.</a:t>
             </a:r>
           </a:p>
           <a:p>
@@ -10480,7 +10503,7 @@
                 <a:cs typeface="Manrope"/>
                 <a:ea typeface="Manrope"/>
               </a:rPr>
-              <a:t>клиент в интерфейсе.</a:t>
+              <a:t>Слева — реальные поля снимка, справа — тот же клиент в интерфейсе.</a:t>
             </a:r>
           </a:p>
         </p:txBody>
@@ -10781,7 +10804,7 @@
                 <a:cs typeface="Manrope SemiBold"/>
                 <a:ea typeface="Manrope SemiBold"/>
               </a:rPr>
-              <a:t>73,3 / 100</a:t>
+              <a:t>71,4 / 100</a:t>
             </a:r>
           </a:p>
         </p:txBody>
@@ -10969,7 +10992,7 @@
                 <a:cs typeface="Manrope Medium"/>
                 <a:ea typeface="Manrope Medium"/>
               </a:rPr>
-              <a:t>1 из 3</a:t>
+              <a:t>2 из 3</a:t>
             </a:r>
           </a:p>
         </p:txBody>
@@ -11218,7 +11241,7 @@
         <p:spPr>
           <a:xfrm>
             <a:off x="4759452" y="2263140"/>
-            <a:ext cx="6805879" cy="410011"/>
+            <a:ext cx="6805879" cy="413652"/>
           </a:xfrm>
           <a:prstGeom prst="rect">
             <a:avLst/>
@@ -11272,7 +11295,7 @@
         <p:spPr>
           <a:xfrm>
             <a:off x="4791456" y="2295144"/>
-            <a:ext cx="6671647" cy="346003"/>
+            <a:ext cx="6741871" cy="349644"/>
           </a:xfrm>
           <a:prstGeom prst="rect">
             <a:avLst/>
@@ -11287,8 +11310,8 @@
         </p:nvSpPr>
         <p:spPr>
           <a:xfrm>
-            <a:off x="4759452" y="2718871"/>
-            <a:ext cx="3361791" cy="1250858"/>
+            <a:off x="4759452" y="2722512"/>
+            <a:ext cx="3361791" cy="1268967"/>
           </a:xfrm>
           <a:prstGeom prst="rect">
             <a:avLst/>
@@ -11341,8 +11364,8 @@
         </p:blipFill>
         <p:spPr>
           <a:xfrm>
-            <a:off x="4791456" y="2750875"/>
-            <a:ext cx="3297783" cy="1186839"/>
+            <a:off x="4791456" y="2754516"/>
+            <a:ext cx="3297783" cy="1204959"/>
           </a:xfrm>
           <a:prstGeom prst="rect">
             <a:avLst/>
@@ -11357,8 +11380,8 @@
         </p:nvSpPr>
         <p:spPr>
           <a:xfrm>
-            <a:off x="8203539" y="2718871"/>
-            <a:ext cx="3361791" cy="1250858"/>
+            <a:off x="8203539" y="2722512"/>
+            <a:ext cx="3361791" cy="1268967"/>
           </a:xfrm>
           <a:prstGeom prst="rect">
             <a:avLst/>
@@ -11411,8 +11434,8 @@
         </p:blipFill>
         <p:spPr>
           <a:xfrm>
-            <a:off x="8235543" y="2750875"/>
-            <a:ext cx="3297783" cy="1186839"/>
+            <a:off x="8235543" y="2754516"/>
+            <a:ext cx="3297783" cy="1204959"/>
           </a:xfrm>
           <a:prstGeom prst="rect">
             <a:avLst/>
@@ -11427,7 +11450,7 @@
         </p:nvSpPr>
         <p:spPr>
           <a:xfrm>
-            <a:off x="4791456" y="4175469"/>
+            <a:off x="4791456" y="4197219"/>
             <a:ext cx="6741871" cy="151003"/>
           </a:xfrm>
           <a:prstGeom prst="rect">
@@ -11474,8 +11497,8 @@
         </p:nvSpPr>
         <p:spPr>
           <a:xfrm>
-            <a:off x="4759452" y="4390353"/>
-            <a:ext cx="6805879" cy="1513779"/>
+            <a:off x="4759452" y="4412103"/>
+            <a:ext cx="6805879" cy="1355554"/>
           </a:xfrm>
           <a:prstGeom prst="rect">
             <a:avLst/>
@@ -11528,8 +11551,8 @@
         </p:blipFill>
         <p:spPr>
           <a:xfrm>
-            <a:off x="4791456" y="4422357"/>
-            <a:ext cx="6697172" cy="1449771"/>
+            <a:off x="4791456" y="4444107"/>
+            <a:ext cx="6741871" cy="1291546"/>
           </a:xfrm>
           <a:prstGeom prst="rect">
             <a:avLst/>
@@ -11544,7 +11567,7 @@
         </p:nvSpPr>
         <p:spPr>
           <a:xfrm>
-            <a:off x="4791456" y="5981856"/>
+            <a:off x="4791456" y="5845381"/>
             <a:ext cx="6741871" cy="364998"/>
           </a:xfrm>
           <a:prstGeom prst="rect">
@@ -11578,7 +11601,7 @@
                 <a:cs typeface="Manrope"/>
                 <a:ea typeface="Manrope"/>
               </a:rPr>
-              <a:t>Почему именно этот клиент: максимальный балл в списке, услуга просрочена на 35 дней, 2 из 2 продлений не</a:t>
+              <a:t>Почему именно этот клиент: максимальный балл в списке, услуга просрочена на 35 дней, ожидает продления,</a:t>
             </a:r>
           </a:p>
           <a:p>
@@ -11602,7 +11625,7 @@
                 <a:cs typeface="Manrope"/>
                 <a:ea typeface="Manrope"/>
               </a:rPr>
-              <a:t>выполнены, автопродление отключено.</a:t>
+              <a:t>автопродление отключено.</a:t>
             </a:r>
           </a:p>
         </p:txBody>
@@ -11896,7 +11919,7 @@
                 <a:cs typeface="Manrope"/>
                 <a:ea typeface="Manrope"/>
               </a:rPr>
-              <a:t>Формула: 100 × Σ(вес × значение) / Σвес. По service-0030 сумма вкладов 11,00 при сумме весов 15,0 → 73,3. Ниже — фактические</a:t>
+              <a:t>Формула: 100 × Σ(вес × значение) / Σвес. По service-0030 сумма вкладов 7,50 при сумме весов 10,5 → 71,4. Ниже — фактические</a:t>
             </a:r>
           </a:p>
           <a:p>
@@ -12013,7 +12036,7 @@
                 <a:cs typeface="Manrope SemiBold"/>
                 <a:ea typeface="Manrope SemiBold"/>
               </a:rPr>
-              <a:t>Вклад факторов в балл 73,3 · service-0030</a:t>
+              <a:t>Вклад факторов в балл 71,4 · service-0030</a:t>
             </a:r>
           </a:p>
         </p:txBody>
@@ -12028,7 +12051,7 @@
         </p:nvGraphicFramePr>
         <p:xfrm>
           <a:off x="822960" y="2571496"/>
-          <a:ext cx="5660136" cy="3280664"/>
+          <a:ext cx="5660136" cy="2933192"/>
         </p:xfrm>
         <a:graphic>
           <a:graphicData uri="http://schemas.openxmlformats.org/drawingml/2006/chart">
@@ -12038,7 +12061,78 @@
       </p:graphicFrame>
       <p:sp>
         <p:nvSpPr>
-          <p:cNvPr id="9" name="Rectangle 8"/>
+          <p:cNvPr id="9" name="TextBox 8"/>
+          <p:cNvSpPr txBox="1"/>
+          <p:nvPr/>
+        </p:nvSpPr>
+        <p:spPr>
+          <a:xfrm>
+            <a:off x="877824" y="5577840"/>
+            <a:ext cx="5550408" cy="297180"/>
+          </a:xfrm>
+          <a:prstGeom prst="rect">
+            <a:avLst/>
+          </a:prstGeom>
+          <a:noFill/>
+        </p:spPr>
+        <p:txBody>
+          <a:bodyPr wrap="square" anchor="t" lIns="0" rIns="0" tIns="0" bIns="0">
+            <a:spAutoFit/>
+          </a:bodyPr>
+          <a:lstStyle/>
+          <a:p>
+            <a:pPr algn="l">
+              <a:lnSpc>
+                <a:spcPct val="122000"/>
+              </a:lnSpc>
+              <a:spcBef>
+                <a:spcPts val="0"/>
+              </a:spcBef>
+              <a:spcAft>
+                <a:spcPts val="0"/>
+              </a:spcAft>
+            </a:pPr>
+            <a:r>
+              <a:rPr sz="900" b="0" i="0">
+                <a:solidFill>
+                  <a:srgbClr val="666666"/>
+                </a:solidFill>
+                <a:latin typeface="Manrope"/>
+                <a:cs typeface="Manrope"/>
+                <a:ea typeface="Manrope"/>
+              </a:rPr>
+              <a:t>Не показаны: доля неуспешных продлений и число неуспешных продлений — за 90 дней попыток не</a:t>
+            </a:r>
+          </a:p>
+          <a:p>
+            <a:pPr algn="l">
+              <a:lnSpc>
+                <a:spcPct val="122000"/>
+              </a:lnSpc>
+              <a:spcBef>
+                <a:spcPts val="0"/>
+              </a:spcBef>
+              <a:spcAft>
+                <a:spcPts val="0"/>
+              </a:spcAft>
+            </a:pPr>
+            <a:r>
+              <a:rPr sz="900" b="0" i="0">
+                <a:solidFill>
+                  <a:srgbClr val="666666"/>
+                </a:solidFill>
+                <a:latin typeface="Manrope"/>
+                <a:cs typeface="Manrope"/>
+                <a:ea typeface="Manrope"/>
+              </a:rPr>
+              <a:t>было, фактор не определён и в знаменатель не входит.</a:t>
+            </a:r>
+          </a:p>
+        </p:txBody>
+      </p:sp>
+      <p:sp>
+        <p:nvSpPr>
+          <p:cNvPr id="10" name="Rectangle 9"/>
           <p:cNvSpPr/>
           <p:nvPr/>
         </p:nvSpPr>
@@ -12084,7 +12178,7 @@
       </p:sp>
       <p:sp>
         <p:nvSpPr>
-          <p:cNvPr id="10" name="Rectangle 9"/>
+          <p:cNvPr id="11" name="Rectangle 10"/>
           <p:cNvSpPr/>
           <p:nvPr/>
         </p:nvSpPr>
@@ -12128,7 +12222,7 @@
       </p:sp>
       <p:sp>
         <p:nvSpPr>
-          <p:cNvPr id="11" name="TextBox 10"/>
+          <p:cNvPr id="12" name="TextBox 11"/>
           <p:cNvSpPr txBox="1"/>
           <p:nvPr/>
         </p:nvSpPr>
@@ -12175,7 +12269,7 @@
       </p:sp>
       <p:sp>
         <p:nvSpPr>
-          <p:cNvPr id="12" name="TextBox 11"/>
+          <p:cNvPr id="13" name="TextBox 12"/>
           <p:cNvSpPr txBox="1"/>
           <p:nvPr/>
         </p:nvSpPr>
@@ -12215,7 +12309,7 @@
                 <a:cs typeface="Manrope"/>
                 <a:ea typeface="Manrope"/>
               </a:rPr>
-              <a:t>Данные снимка: expiresAt 14.09.2026, autoProlong = false, 2</a:t>
+              <a:t>Данные снимка: услуга истекла 35 дней назад, autoProlong = false,</a:t>
             </a:r>
           </a:p>
           <a:p>
@@ -12239,14 +12333,14 @@
                 <a:cs typeface="Manrope"/>
                 <a:ea typeface="Manrope"/>
               </a:rPr>
-              <a:t>продления из 2 со статусом not_performed.</a:t>
-            </a:r>
-          </a:p>
-        </p:txBody>
-      </p:sp>
-      <p:sp>
-        <p:nvSpPr>
-          <p:cNvPr id="13" name="Rectangle 12"/>
+              <a:t>статус prolong_wait.</a:t>
+            </a:r>
+          </a:p>
+        </p:txBody>
+      </p:sp>
+      <p:sp>
+        <p:nvSpPr>
+          <p:cNvPr id="14" name="Rectangle 13"/>
           <p:cNvSpPr/>
           <p:nvPr/>
         </p:nvSpPr>
@@ -12292,7 +12386,7 @@
       </p:sp>
       <p:sp>
         <p:nvSpPr>
-          <p:cNvPr id="14" name="Rectangle 13"/>
+          <p:cNvPr id="15" name="Rectangle 14"/>
           <p:cNvSpPr/>
           <p:nvPr/>
         </p:nvSpPr>
@@ -12336,7 +12430,7 @@
       </p:sp>
       <p:sp>
         <p:nvSpPr>
-          <p:cNvPr id="15" name="TextBox 14"/>
+          <p:cNvPr id="16" name="TextBox 15"/>
           <p:cNvSpPr txBox="1"/>
           <p:nvPr/>
         </p:nvSpPr>
@@ -12383,7 +12477,7 @@
       </p:sp>
       <p:sp>
         <p:nvSpPr>
-          <p:cNvPr id="16" name="TextBox 15"/>
+          <p:cNvPr id="17" name="TextBox 16"/>
           <p:cNvSpPr txBox="1"/>
           <p:nvPr/>
         </p:nvSpPr>
@@ -12423,7 +12517,7 @@
                 <a:cs typeface="Manrope"/>
                 <a:ea typeface="Manrope"/>
               </a:rPr>
-              <a:t>Услуга просрочена, продление не завершено, решение о продлении</a:t>
+              <a:t>Услуга просрочена и ждёт продления, а решение о продлении</a:t>
             </a:r>
           </a:p>
           <a:p>
@@ -12447,14 +12541,14 @@
                 <a:cs typeface="Manrope"/>
                 <a:ea typeface="Manrope"/>
               </a:rPr>
-              <a:t>зависит от клиента.</a:t>
-            </a:r>
-          </a:p>
-        </p:txBody>
-      </p:sp>
-      <p:sp>
-        <p:nvSpPr>
-          <p:cNvPr id="17" name="Rectangle 16"/>
+              <a:t>зависит от клиента, потому что автопродление выключено.</a:t>
+            </a:r>
+          </a:p>
+        </p:txBody>
+      </p:sp>
+      <p:sp>
+        <p:nvSpPr>
+          <p:cNvPr id="18" name="Rectangle 17"/>
           <p:cNvSpPr/>
           <p:nvPr/>
         </p:nvSpPr>
@@ -12500,7 +12594,7 @@
       </p:sp>
       <p:sp>
         <p:nvSpPr>
-          <p:cNvPr id="18" name="Rectangle 17"/>
+          <p:cNvPr id="19" name="Rectangle 18"/>
           <p:cNvSpPr/>
           <p:nvPr/>
         </p:nvSpPr>
@@ -12544,7 +12638,7 @@
       </p:sp>
       <p:sp>
         <p:nvSpPr>
-          <p:cNvPr id="19" name="TextBox 18"/>
+          <p:cNvPr id="20" name="TextBox 19"/>
           <p:cNvSpPr txBox="1"/>
           <p:nvPr/>
         </p:nvSpPr>
@@ -12591,14 +12685,14 @@
       </p:sp>
       <p:sp>
         <p:nvSpPr>
-          <p:cNvPr id="20" name="TextBox 19"/>
+          <p:cNvPr id="21" name="TextBox 20"/>
           <p:cNvSpPr txBox="1"/>
           <p:nvPr/>
         </p:nvSpPr>
         <p:spPr>
           <a:xfrm>
             <a:off x="7123176" y="5200564"/>
-            <a:ext cx="4208983" cy="505968"/>
+            <a:ext cx="4208983" cy="668528"/>
           </a:xfrm>
           <a:prstGeom prst="rect">
             <a:avLst/>
@@ -12631,7 +12725,7 @@
                 <a:cs typeface="Manrope"/>
                 <a:ea typeface="Manrope"/>
               </a:rPr>
-              <a:t>Три крупнейших фактора дают 3,0 + 2,5 + 2,0 = 7,5 из 15,0. С</a:t>
+              <a:t>Три сработавших фактора дают 3,0 + 2,5 + 2,0 = 7,5. Остальные</a:t>
             </a:r>
           </a:p>
           <a:p>
@@ -12655,7 +12749,7 @@
                 <a:cs typeface="Manrope"/>
                 <a:ea typeface="Manrope"/>
               </a:rPr>
-              <a:t>неуспешными продлениями и их долей (2,0 + 1,5) сумма вкладов 11,0</a:t>
+              <a:t>четыре либо равны нулю, либо не определены (нет попыток</a:t>
             </a:r>
           </a:p>
           <a:p>
@@ -12679,14 +12773,38 @@
                 <a:cs typeface="Manrope"/>
                 <a:ea typeface="Manrope"/>
               </a:rPr>
-              <a:t>из 15,0 — отсюда 73,3, выше порога 65.</a:t>
-            </a:r>
-          </a:p>
-        </p:txBody>
-      </p:sp>
-      <p:sp>
-        <p:nvSpPr>
-          <p:cNvPr id="21" name="Rectangle 20"/>
+              <a:t>продления за 90 дней) и в знаменатель не входят: 100 × 7,5 / 10,5 =</a:t>
+            </a:r>
+          </a:p>
+          <a:p>
+            <a:pPr algn="l">
+              <a:lnSpc>
+                <a:spcPct val="128000"/>
+              </a:lnSpc>
+              <a:spcBef>
+                <a:spcPts val="0"/>
+              </a:spcBef>
+              <a:spcAft>
+                <a:spcPts val="0"/>
+              </a:spcAft>
+            </a:pPr>
+            <a:r>
+              <a:rPr sz="1000" b="0" i="0">
+                <a:solidFill>
+                  <a:srgbClr val="666666"/>
+                </a:solidFill>
+                <a:latin typeface="Manrope"/>
+                <a:cs typeface="Manrope"/>
+                <a:ea typeface="Manrope"/>
+              </a:rPr>
+              <a:t>71,4 — выше порога 65.</a:t>
+            </a:r>
+          </a:p>
+        </p:txBody>
+      </p:sp>
+      <p:sp>
+        <p:nvSpPr>
+          <p:cNvPr id="22" name="Rectangle 21"/>
           <p:cNvSpPr/>
           <p:nvPr/>
         </p:nvSpPr>
@@ -12730,7 +12848,7 @@
       </p:sp>
       <p:sp>
         <p:nvSpPr>
-          <p:cNvPr id="22" name="TextBox 21"/>
+          <p:cNvPr id="23" name="TextBox 22"/>
           <p:cNvSpPr txBox="1"/>
           <p:nvPr/>
         </p:nvSpPr>
@@ -13381,7 +13499,7 @@
                 <a:cs typeface="Manrope SemiBold"/>
                 <a:ea typeface="Manrope SemiBold"/>
               </a:rPr>
-              <a:t>73,3 / 100</a:t>
+              <a:t>71,4 / 100</a:t>
             </a:r>
           </a:p>
         </p:txBody>
@@ -13818,7 +13936,7 @@
         <p:spPr>
           <a:xfrm>
             <a:off x="4878323" y="3323844"/>
-            <a:ext cx="6687008" cy="1462829"/>
+            <a:ext cx="6687008" cy="1948137"/>
           </a:xfrm>
           <a:prstGeom prst="rect">
             <a:avLst/>
@@ -13872,7 +13990,7 @@
         <p:spPr>
           <a:xfrm>
             <a:off x="4910327" y="3355848"/>
-            <a:ext cx="6615883" cy="1398821"/>
+            <a:ext cx="6623000" cy="1884129"/>
           </a:xfrm>
           <a:prstGeom prst="rect">
             <a:avLst/>
@@ -13887,8 +14005,8 @@
         </p:nvSpPr>
         <p:spPr>
           <a:xfrm>
-            <a:off x="4910327" y="4965192"/>
-            <a:ext cx="2134514" cy="1088136"/>
+            <a:off x="4910327" y="5477721"/>
+            <a:ext cx="2134514" cy="575607"/>
           </a:xfrm>
           <a:prstGeom prst="rect">
             <a:avLst/>
@@ -13933,7 +14051,7 @@
         </p:nvSpPr>
         <p:spPr>
           <a:xfrm>
-            <a:off x="5038343" y="5093208"/>
+            <a:off x="5038343" y="5605737"/>
             <a:ext cx="1878482" cy="130048"/>
           </a:xfrm>
           <a:prstGeom prst="rect">
@@ -13980,7 +14098,7 @@
         </p:nvSpPr>
         <p:spPr>
           <a:xfrm>
-            <a:off x="5038343" y="5330952"/>
+            <a:off x="5038343" y="5843481"/>
             <a:ext cx="1878482" cy="221487"/>
           </a:xfrm>
           <a:prstGeom prst="rect">
@@ -14014,7 +14132,7 @@
                 <a:cs typeface="Manrope"/>
                 <a:ea typeface="Manrope"/>
               </a:rPr>
-              <a:t>5,74 €</a:t>
+              <a:t>5,80 €</a:t>
             </a:r>
           </a:p>
         </p:txBody>
@@ -14027,7 +14145,7 @@
         </p:nvSpPr>
         <p:spPr>
           <a:xfrm>
-            <a:off x="5038343" y="5641848"/>
+            <a:off x="5038343" y="6154377"/>
             <a:ext cx="1878482" cy="142430"/>
           </a:xfrm>
           <a:prstGeom prst="rect">
@@ -14074,8 +14192,8 @@
         </p:nvSpPr>
         <p:spPr>
           <a:xfrm>
-            <a:off x="7154569" y="4965192"/>
-            <a:ext cx="2134514" cy="1088136"/>
+            <a:off x="7154569" y="5477721"/>
+            <a:ext cx="2134514" cy="575607"/>
           </a:xfrm>
           <a:prstGeom prst="rect">
             <a:avLst/>
@@ -14120,7 +14238,7 @@
         </p:nvSpPr>
         <p:spPr>
           <a:xfrm>
-            <a:off x="7282585" y="5093208"/>
+            <a:off x="7282585" y="5605737"/>
             <a:ext cx="1878482" cy="130048"/>
           </a:xfrm>
           <a:prstGeom prst="rect">
@@ -14167,7 +14285,7 @@
         </p:nvSpPr>
         <p:spPr>
           <a:xfrm>
-            <a:off x="7282585" y="5330952"/>
+            <a:off x="7282585" y="5843481"/>
             <a:ext cx="1878482" cy="221487"/>
           </a:xfrm>
           <a:prstGeom prst="rect">
@@ -14214,7 +14332,7 @@
         </p:nvSpPr>
         <p:spPr>
           <a:xfrm>
-            <a:off x="7282585" y="5641848"/>
+            <a:off x="7282585" y="6154377"/>
             <a:ext cx="1878482" cy="142430"/>
           </a:xfrm>
           <a:prstGeom prst="rect">
@@ -14261,8 +14379,8 @@
         </p:nvSpPr>
         <p:spPr>
           <a:xfrm>
-            <a:off x="9398811" y="4965192"/>
-            <a:ext cx="2134514" cy="1088136"/>
+            <a:off x="9398811" y="5477721"/>
+            <a:ext cx="2134514" cy="575607"/>
           </a:xfrm>
           <a:prstGeom prst="rect">
             <a:avLst/>
@@ -14307,7 +14425,7 @@
         </p:nvSpPr>
         <p:spPr>
           <a:xfrm>
-            <a:off x="9526827" y="5093208"/>
+            <a:off x="9526827" y="5605737"/>
             <a:ext cx="1878482" cy="130048"/>
           </a:xfrm>
           <a:prstGeom prst="rect">
@@ -14354,7 +14472,7 @@
         </p:nvSpPr>
         <p:spPr>
           <a:xfrm>
-            <a:off x="9526827" y="5330952"/>
+            <a:off x="9526827" y="5843481"/>
             <a:ext cx="1878482" cy="221487"/>
           </a:xfrm>
           <a:prstGeom prst="rect">
@@ -14401,7 +14519,7 @@
         </p:nvSpPr>
         <p:spPr>
           <a:xfrm>
-            <a:off x="9526827" y="5641848"/>
+            <a:off x="9526827" y="6154377"/>
             <a:ext cx="1878482" cy="142430"/>
           </a:xfrm>
           <a:prstGeom prst="rect">
@@ -14493,7 +14611,7 @@
         <p:spPr>
           <a:xfrm>
             <a:off x="658368" y="6355080"/>
-            <a:ext cx="10874959" cy="163067"/>
+            <a:ext cx="10874959" cy="307848"/>
           </a:xfrm>
           <a:prstGeom prst="rect">
             <a:avLst/>
@@ -14526,7 +14644,31 @@
                 <a:cs typeface="Manrope"/>
                 <a:ea typeface="Manrope"/>
               </a:rPr>
-              <a:t>Горизонт 30 дней. Сумма по четырём продлениям: 0,32 + 0,77 + 1,57 + 3,08 = 5,74 €. Оценка не является гарантированным прогнозом потерь.</a:t>
+              <a:t>Горизонт 30 дней. Четыре продления в горизонте стоят 0,95 + 2,34 + 5,47 + 8,27 = 17,03 €; из них под риском 0,36 + 0,70 + 1,81 + 2,93 = 5,80 €. Оценка не является гарантированным</a:t>
+            </a:r>
+          </a:p>
+          <a:p>
+            <a:pPr algn="l">
+              <a:lnSpc>
+                <a:spcPct val="120000"/>
+              </a:lnSpc>
+              <a:spcBef>
+                <a:spcPts val="0"/>
+              </a:spcBef>
+              <a:spcAft>
+                <a:spcPts val="0"/>
+              </a:spcAft>
+            </a:pPr>
+            <a:r>
+              <a:rPr sz="950" b="0" i="0">
+                <a:solidFill>
+                  <a:srgbClr val="666666"/>
+                </a:solidFill>
+                <a:latin typeface="Manrope"/>
+                <a:cs typeface="Manrope"/>
+                <a:ea typeface="Manrope"/>
+              </a:rPr>
+              <a:t>прогнозом потерь.</a:t>
             </a:r>
           </a:p>
         </p:txBody>
@@ -15009,7 +15151,7 @@
         <p:spPr>
           <a:xfrm>
             <a:off x="626364" y="2921508"/>
-            <a:ext cx="5346039" cy="1978550"/>
+            <a:ext cx="5346039" cy="531102"/>
           </a:xfrm>
           <a:prstGeom prst="rect">
             <a:avLst/>
@@ -15063,7 +15205,7 @@
         <p:spPr>
           <a:xfrm>
             <a:off x="658368" y="2953512"/>
-            <a:ext cx="5282031" cy="1900950"/>
+            <a:ext cx="5282031" cy="467094"/>
           </a:xfrm>
           <a:prstGeom prst="rect">
             <a:avLst/>
@@ -15079,7 +15221,7 @@
         <p:spPr>
           <a:xfrm>
             <a:off x="6219291" y="2921508"/>
-            <a:ext cx="5346039" cy="1978550"/>
+            <a:ext cx="5346039" cy="531102"/>
           </a:xfrm>
           <a:prstGeom prst="rect">
             <a:avLst/>
@@ -15133,7 +15275,7 @@
         <p:spPr>
           <a:xfrm>
             <a:off x="6251295" y="2953512"/>
-            <a:ext cx="5282031" cy="1900950"/>
+            <a:ext cx="3666512" cy="467094"/>
           </a:xfrm>
           <a:prstGeom prst="rect">
             <a:avLst/>
@@ -15275,7 +15417,7 @@
                 <a:cs typeface="Manrope Medium"/>
                 <a:ea typeface="Manrope Medium"/>
               </a:rPr>
-              <a:t>73,3</a:t>
+              <a:t>71,4</a:t>
             </a:r>
             <a:r>
               <a:rPr sz="1500" b="0">
@@ -15297,7 +15439,7 @@
                 <a:cs typeface="Manrope"/>
                 <a:ea typeface="Manrope"/>
               </a:rPr>
-              <a:t>81,0</a:t>
+              <a:t>81,8</a:t>
             </a:r>
           </a:p>
         </p:txBody>
@@ -15437,7 +15579,7 @@
                 <a:cs typeface="Manrope Medium"/>
                 <a:ea typeface="Manrope Medium"/>
               </a:rPr>
-              <a:t>73,3</a:t>
+              <a:t>71,4</a:t>
             </a:r>
             <a:r>
               <a:rPr sz="1500" b="0">
@@ -15459,7 +15601,7 @@
                 <a:cs typeface="Manrope"/>
                 <a:ea typeface="Manrope"/>
               </a:rPr>
-              <a:t>81,0</a:t>
+              <a:t>81,8</a:t>
             </a:r>
           </a:p>
         </p:txBody>
@@ -15552,7 +15694,7 @@
                 <a:cs typeface="Manrope SemiBold"/>
                 <a:ea typeface="Manrope SemiBold"/>
               </a:rPr>
-              <a:t>Клиентов высокого риска</a:t>
+              <a:t>Услуг высокого риска</a:t>
             </a:r>
           </a:p>
         </p:txBody>
@@ -15599,7 +15741,7 @@
                 <a:cs typeface="Manrope Medium"/>
                 <a:ea typeface="Manrope Medium"/>
               </a:rPr>
-              <a:t>2</a:t>
+              <a:t>4</a:t>
             </a:r>
             <a:r>
               <a:rPr sz="1500" b="0">
@@ -15621,7 +15763,7 @@
                 <a:cs typeface="Manrope"/>
                 <a:ea typeface="Manrope"/>
               </a:rPr>
-              <a:t>3</a:t>
+              <a:t>7</a:t>
             </a:r>
           </a:p>
         </p:txBody>
@@ -15714,7 +15856,7 @@
                 <a:cs typeface="Manrope SemiBold"/>
                 <a:ea typeface="Manrope SemiBold"/>
               </a:rPr>
-              <a:t>Клиентов среднего риска</a:t>
+              <a:t>Выручка под риском</a:t>
             </a:r>
           </a:p>
         </p:txBody>
@@ -15761,7 +15903,7 @@
                 <a:cs typeface="Manrope Medium"/>
                 <a:ea typeface="Manrope Medium"/>
               </a:rPr>
-              <a:t>4</a:t>
+              <a:t>5,80 €</a:t>
             </a:r>
             <a:r>
               <a:rPr sz="1500" b="0">
@@ -15783,7 +15925,7 @@
                 <a:cs typeface="Manrope"/>
                 <a:ea typeface="Manrope"/>
               </a:rPr>
-              <a:t>3</a:t>
+              <a:t>7,72 €</a:t>
             </a:r>
           </a:p>
         </p:txBody>
@@ -15876,7 +16018,7 @@
                 <a:cs typeface="Manrope SemiBold"/>
                 <a:ea typeface="Manrope SemiBold"/>
               </a:rPr>
-              <a:t>Выручка под риском</a:t>
+              <a:t>Сумма весов по услуге</a:t>
             </a:r>
           </a:p>
         </p:txBody>
@@ -15923,7 +16065,7 @@
                 <a:cs typeface="Manrope Medium"/>
                 <a:ea typeface="Manrope Medium"/>
               </a:rPr>
-              <a:t>5,74 €</a:t>
+              <a:t>10,5</a:t>
             </a:r>
             <a:r>
               <a:rPr sz="1500" b="0">
@@ -15945,7 +16087,7 @@
                 <a:cs typeface="Manrope"/>
                 <a:ea typeface="Manrope"/>
               </a:rPr>
-              <a:t>7,48 €</a:t>
+              <a:t>16,5</a:t>
             </a:r>
           </a:p>
         </p:txBody>
@@ -16038,7 +16180,7 @@
                 <a:cs typeface="Manrope SemiBold"/>
                 <a:ea typeface="Manrope SemiBold"/>
               </a:rPr>
-              <a:t>Сумма весов</a:t>
+              <a:t>Сумма весов модели</a:t>
             </a:r>
           </a:p>
         </p:txBody>
@@ -16085,7 +16227,7 @@
                 <a:cs typeface="Manrope Medium"/>
                 <a:ea typeface="Manrope Medium"/>
               </a:rPr>
-              <a:t>15,0</a:t>
+              <a:t>13,0</a:t>
             </a:r>
             <a:r>
               <a:rPr sz="1500" b="0">
@@ -16107,7 +16249,7 @@
                 <a:cs typeface="Manrope"/>
                 <a:ea typeface="Manrope"/>
               </a:rPr>
-              <a:t>21,0</a:t>
+              <a:t>19,0</a:t>
             </a:r>
           </a:p>
         </p:txBody>
@@ -16121,7 +16263,7 @@
         <p:spPr>
           <a:xfrm>
             <a:off x="658368" y="5641848"/>
-            <a:ext cx="10874959" cy="364998"/>
+            <a:ext cx="10874959" cy="538353"/>
           </a:xfrm>
           <a:prstGeom prst="rect">
             <a:avLst/>
@@ -16154,7 +16296,7 @@
                 <a:cs typeface="Manrope"/>
                 <a:ea typeface="Manrope"/>
               </a:rPr>
-              <a:t>Расчёт: сумма весов выросла с 15,0 до 21,0, вклад фактора — с 3,0 до 9,0, поэтому 100 × 17,0 / 21,0 = 81,0. Настройка сохраняется на сервере, сводка обновляется сразу, без</a:t>
+              <a:t>Расчёт: по service-0030 сумма весов выросла с 10,5 до 16,5, вклад фактора — с 3,0 до 9,0, поэтому 100 × 13,5 / 16,5 = 81,8. Категории клиентов (3 высокий / 3 средний) не сдвинулись:</a:t>
             </a:r>
           </a:p>
           <a:p>
@@ -16178,7 +16320,31 @@
                 <a:cs typeface="Manrope"/>
                 <a:ea typeface="Manrope"/>
               </a:rPr>
-              <a:t>перезагрузки страницы; кнопка «Значения по умолчанию» возвращает исходные 3,0 и прежние числа.</a:t>
+              <a:t>вес усилил сигналы, но не перевёл никого через порог. Настройка сохраняется на сервере, сводка обновляется сразу, без перезагрузки страницы; кнопка «Значения по</a:t>
+            </a:r>
+          </a:p>
+          <a:p>
+            <a:pPr algn="l">
+              <a:lnSpc>
+                <a:spcPct val="130000"/>
+              </a:lnSpc>
+              <a:spcBef>
+                <a:spcPts val="0"/>
+              </a:spcBef>
+              <a:spcAft>
+                <a:spcPts val="0"/>
+              </a:spcAft>
+            </a:pPr>
+            <a:r>
+              <a:rPr sz="1050" b="0" i="0">
+                <a:solidFill>
+                  <a:srgbClr val="666666"/>
+                </a:solidFill>
+                <a:latin typeface="Manrope"/>
+                <a:cs typeface="Manrope"/>
+                <a:ea typeface="Manrope"/>
+              </a:rPr>
+              <a:t>умолчанию» возвращает исходные 3,0 и прежние числа.</a:t>
             </a:r>
           </a:p>
         </p:txBody>

</xml_diff>